<commit_message>
ooo and superscalar intro
</commit_message>
<xml_diff>
--- a/Lec-22-23-microarchitecture-wrap-up.pptx
+++ b/Lec-22-23-microarchitecture-wrap-up.pptx
@@ -5,18 +5,23 @@
     <p:sldMasterId id="2147483648" r:id="rId1"/>
   </p:sldMasterIdLst>
   <p:notesMasterIdLst>
-    <p:notesMasterId r:id="rId11"/>
+    <p:notesMasterId r:id="rId16"/>
   </p:notesMasterIdLst>
   <p:sldIdLst>
     <p:sldId id="337" r:id="rId2"/>
-    <p:sldId id="360" r:id="rId3"/>
-    <p:sldId id="361" r:id="rId4"/>
-    <p:sldId id="362" r:id="rId5"/>
-    <p:sldId id="363" r:id="rId6"/>
-    <p:sldId id="364" r:id="rId7"/>
-    <p:sldId id="365" r:id="rId8"/>
-    <p:sldId id="366" r:id="rId9"/>
-    <p:sldId id="359" r:id="rId10"/>
+    <p:sldId id="361" r:id="rId3"/>
+    <p:sldId id="362" r:id="rId4"/>
+    <p:sldId id="363" r:id="rId5"/>
+    <p:sldId id="364" r:id="rId6"/>
+    <p:sldId id="365" r:id="rId7"/>
+    <p:sldId id="366" r:id="rId8"/>
+    <p:sldId id="368" r:id="rId9"/>
+    <p:sldId id="367" r:id="rId10"/>
+    <p:sldId id="369" r:id="rId11"/>
+    <p:sldId id="370" r:id="rId12"/>
+    <p:sldId id="372" r:id="rId13"/>
+    <p:sldId id="373" r:id="rId14"/>
+    <p:sldId id="371" r:id="rId15"/>
   </p:sldIdLst>
   <p:sldSz cx="9144000" cy="6858000" type="screen4x3"/>
   <p:notesSz cx="6858000" cy="9144000"/>
@@ -298,7 +303,7 @@
               <a:pPr>
                 <a:defRPr/>
               </a:pPr>
-              <a:t>3/18/2026</a:t>
+              <a:t>3/20/2026</a:t>
             </a:fld>
             <a:endParaRPr lang="en-US"/>
           </a:p>
@@ -5905,7 +5910,7 @@
 </p:sld>
 </file>
 
-<file path=ppt/slides/slide2.xml><?xml version="1.0" encoding="utf-8"?>
+<file path=ppt/slides/slide10.xml><?xml version="1.0" encoding="utf-8"?>
 <p:sld xmlns:a="http://schemas.openxmlformats.org/drawingml/2006/main" xmlns:r="http://schemas.openxmlformats.org/officeDocument/2006/relationships" xmlns:p="http://schemas.openxmlformats.org/presentationml/2006/main">
   <p:cSld>
     <p:spTree>
@@ -5927,7 +5932,7 @@
           <p:cNvPr id="2" name="Title 1">
             <a:extLst>
               <a:ext uri="{FF2B5EF4-FFF2-40B4-BE49-F238E27FC236}">
-                <a16:creationId xmlns:a16="http://schemas.microsoft.com/office/drawing/2014/main" id="{09F307A0-3833-2C72-0319-4EE631EE78A4}"/>
+                <a16:creationId xmlns:a16="http://schemas.microsoft.com/office/drawing/2014/main" id="{AFA5A8B5-4DC2-FEA0-3212-9CD85424DF29}"/>
               </a:ext>
             </a:extLst>
           </p:cNvPr>
@@ -5945,7 +5950,7 @@
           <a:p>
             <a:r>
               <a:rPr lang="en-US" dirty="0"/>
-              <a:t>The computer we have built so far</a:t>
+              <a:t>What can happen in parallel</a:t>
             </a:r>
             <a:endParaRPr lang="en-IN" dirty="0"/>
           </a:p>
@@ -5956,7 +5961,7 @@
           <p:cNvPr id="3" name="Content Placeholder 2">
             <a:extLst>
               <a:ext uri="{FF2B5EF4-FFF2-40B4-BE49-F238E27FC236}">
-                <a16:creationId xmlns:a16="http://schemas.microsoft.com/office/drawing/2014/main" id="{3997ACB7-2333-0EE2-307D-F64BCD604928}"/>
+                <a16:creationId xmlns:a16="http://schemas.microsoft.com/office/drawing/2014/main" id="{7C7A2646-68D1-0614-91AA-949A3CBF7A3C}"/>
               </a:ext>
             </a:extLst>
           </p:cNvPr>
@@ -5972,7 +5977,43 @@
           <a:bodyPr/>
           <a:lstStyle/>
           <a:p>
-            <a:endParaRPr lang="en-IN"/>
+            <a:r>
+              <a:rPr lang="en-US" dirty="0"/>
+              <a:t>Only independent instructions can be executed in parallel</a:t>
+            </a:r>
+          </a:p>
+          <a:p>
+            <a:r>
+              <a:rPr lang="en-US" dirty="0"/>
+              <a:t>What if there are independent instructions, but not one after the other?</a:t>
+            </a:r>
+          </a:p>
+          <a:p>
+            <a:endParaRPr lang="en-US" dirty="0"/>
+          </a:p>
+          <a:p>
+            <a:endParaRPr lang="en-US" dirty="0"/>
+          </a:p>
+          <a:p>
+            <a:r>
+              <a:rPr lang="en-US" dirty="0"/>
+              <a:t>Parallel pipeline would stall at 2, but can execute 3 instead</a:t>
+            </a:r>
+          </a:p>
+          <a:p>
+            <a:r>
+              <a:rPr lang="en-US" dirty="0"/>
+              <a:t>Out of Order (</a:t>
+            </a:r>
+            <a:r>
+              <a:rPr lang="en-US" dirty="0" err="1"/>
+              <a:t>OoO</a:t>
+            </a:r>
+            <a:r>
+              <a:rPr lang="en-US" dirty="0"/>
+              <a:t>) execution</a:t>
+            </a:r>
+            <a:endParaRPr lang="en-IN" dirty="0"/>
           </a:p>
         </p:txBody>
       </p:sp>
@@ -5981,7 +6022,7 @@
           <p:cNvPr id="4" name="Date Placeholder 3">
             <a:extLst>
               <a:ext uri="{FF2B5EF4-FFF2-40B4-BE49-F238E27FC236}">
-                <a16:creationId xmlns:a16="http://schemas.microsoft.com/office/drawing/2014/main" id="{AEE03B21-4E16-83E5-272B-069DDD45F5C4}"/>
+                <a16:creationId xmlns:a16="http://schemas.microsoft.com/office/drawing/2014/main" id="{12B2958E-37FB-56DF-BB24-3C6133F802C6}"/>
               </a:ext>
             </a:extLst>
           </p:cNvPr>
@@ -6012,7 +6053,7 @@
           <p:cNvPr id="5" name="Slide Number Placeholder 4">
             <a:extLst>
               <a:ext uri="{FF2B5EF4-FFF2-40B4-BE49-F238E27FC236}">
-                <a16:creationId xmlns:a16="http://schemas.microsoft.com/office/drawing/2014/main" id="{833CA3C0-7BC3-8AD5-8F6D-5E7F7353C464}"/>
+                <a16:creationId xmlns:a16="http://schemas.microsoft.com/office/drawing/2014/main" id="{7E184956-282C-698D-7E80-7FF4E5B6C419}"/>
               </a:ext>
             </a:extLst>
           </p:cNvPr>
@@ -6036,26 +6077,2641 @@
               <a:pPr>
                 <a:defRPr/>
               </a:pPr>
-              <a:t>2</a:t>
+              <a:t>10</a:t>
             </a:fld>
             <a:endParaRPr lang="en-US" altLang="en-US"/>
+          </a:p>
+        </p:txBody>
+      </p:sp>
+      <p:sp>
+        <p:nvSpPr>
+          <p:cNvPr id="7" name="TextBox 6">
+            <a:extLst>
+              <a:ext uri="{FF2B5EF4-FFF2-40B4-BE49-F238E27FC236}">
+                <a16:creationId xmlns:a16="http://schemas.microsoft.com/office/drawing/2014/main" id="{F826A415-3A92-AF29-E108-03667963D23F}"/>
+              </a:ext>
+            </a:extLst>
+          </p:cNvPr>
+          <p:cNvSpPr txBox="1"/>
+          <p:nvPr/>
+        </p:nvSpPr>
+        <p:spPr>
+          <a:xfrm>
+            <a:off x="2209800" y="3657600"/>
+            <a:ext cx="4588328" cy="923330"/>
+          </a:xfrm>
+          <a:prstGeom prst="rect">
+            <a:avLst/>
+          </a:prstGeom>
+          <a:noFill/>
+        </p:spPr>
+        <p:txBody>
+          <a:bodyPr wrap="square">
+            <a:spAutoFit/>
+          </a:bodyPr>
+          <a:lstStyle/>
+          <a:p>
+            <a:r>
+              <a:rPr lang="en-US" b="1" dirty="0">
+                <a:solidFill>
+                  <a:srgbClr val="FFC000"/>
+                </a:solidFill>
+                <a:latin typeface="Cascadia Code" panose="020B0609020000020004" pitchFamily="49" charset="0"/>
+                <a:ea typeface="Cascadia Code" panose="020B0609020000020004" pitchFamily="49" charset="0"/>
+                <a:cs typeface="Cascadia Code" panose="020B0609020000020004" pitchFamily="49" charset="0"/>
+              </a:rPr>
+              <a:t>1: add x1, x2, x3</a:t>
+            </a:r>
+            <a:br>
+              <a:rPr lang="en-US" b="1" dirty="0">
+                <a:solidFill>
+                  <a:srgbClr val="FFC000"/>
+                </a:solidFill>
+                <a:latin typeface="Cascadia Code" panose="020B0609020000020004" pitchFamily="49" charset="0"/>
+                <a:ea typeface="Cascadia Code" panose="020B0609020000020004" pitchFamily="49" charset="0"/>
+                <a:cs typeface="Cascadia Code" panose="020B0609020000020004" pitchFamily="49" charset="0"/>
+              </a:rPr>
+            </a:br>
+            <a:r>
+              <a:rPr lang="en-US" b="1" dirty="0">
+                <a:solidFill>
+                  <a:srgbClr val="FFC000"/>
+                </a:solidFill>
+                <a:latin typeface="Cascadia Code" panose="020B0609020000020004" pitchFamily="49" charset="0"/>
+                <a:ea typeface="Cascadia Code" panose="020B0609020000020004" pitchFamily="49" charset="0"/>
+                <a:cs typeface="Cascadia Code" panose="020B0609020000020004" pitchFamily="49" charset="0"/>
+              </a:rPr>
+              <a:t>2: sub x4, x1, x5 ← dependent</a:t>
+            </a:r>
+            <a:br>
+              <a:rPr lang="en-US" b="1" dirty="0">
+                <a:solidFill>
+                  <a:srgbClr val="FFC000"/>
+                </a:solidFill>
+                <a:latin typeface="Cascadia Code" panose="020B0609020000020004" pitchFamily="49" charset="0"/>
+                <a:ea typeface="Cascadia Code" panose="020B0609020000020004" pitchFamily="49" charset="0"/>
+                <a:cs typeface="Cascadia Code" panose="020B0609020000020004" pitchFamily="49" charset="0"/>
+              </a:rPr>
+            </a:br>
+            <a:r>
+              <a:rPr lang="en-US" b="1" dirty="0">
+                <a:solidFill>
+                  <a:srgbClr val="FFC000"/>
+                </a:solidFill>
+                <a:latin typeface="Cascadia Code" panose="020B0609020000020004" pitchFamily="49" charset="0"/>
+                <a:ea typeface="Cascadia Code" panose="020B0609020000020004" pitchFamily="49" charset="0"/>
+                <a:cs typeface="Cascadia Code" panose="020B0609020000020004" pitchFamily="49" charset="0"/>
+              </a:rPr>
+              <a:t>3: </a:t>
+            </a:r>
+            <a:r>
+              <a:rPr lang="en-US" b="1" dirty="0" err="1">
+                <a:solidFill>
+                  <a:srgbClr val="FFC000"/>
+                </a:solidFill>
+                <a:latin typeface="Cascadia Code" panose="020B0609020000020004" pitchFamily="49" charset="0"/>
+                <a:ea typeface="Cascadia Code" panose="020B0609020000020004" pitchFamily="49" charset="0"/>
+                <a:cs typeface="Cascadia Code" panose="020B0609020000020004" pitchFamily="49" charset="0"/>
+              </a:rPr>
+              <a:t>mul</a:t>
+            </a:r>
+            <a:r>
+              <a:rPr lang="en-US" b="1" dirty="0">
+                <a:solidFill>
+                  <a:srgbClr val="FFC000"/>
+                </a:solidFill>
+                <a:latin typeface="Cascadia Code" panose="020B0609020000020004" pitchFamily="49" charset="0"/>
+                <a:ea typeface="Cascadia Code" panose="020B0609020000020004" pitchFamily="49" charset="0"/>
+                <a:cs typeface="Cascadia Code" panose="020B0609020000020004" pitchFamily="49" charset="0"/>
+              </a:rPr>
+              <a:t> x6, x7, x8 ← independent</a:t>
+            </a:r>
+            <a:endParaRPr lang="en-IN" b="1" dirty="0">
+              <a:solidFill>
+                <a:srgbClr val="FFC000"/>
+              </a:solidFill>
+              <a:latin typeface="Cascadia Code" panose="020B0609020000020004" pitchFamily="49" charset="0"/>
+              <a:ea typeface="Cascadia Code" panose="020B0609020000020004" pitchFamily="49" charset="0"/>
+              <a:cs typeface="Cascadia Code" panose="020B0609020000020004" pitchFamily="49" charset="0"/>
+            </a:endParaRPr>
           </a:p>
         </p:txBody>
       </p:sp>
     </p:spTree>
     <p:extLst>
       <p:ext uri="{BB962C8B-B14F-4D97-AF65-F5344CB8AC3E}">
-        <p14:creationId xmlns:p14="http://schemas.microsoft.com/office/powerpoint/2010/main" val="3383698250"/>
+        <p14:creationId xmlns:p14="http://schemas.microsoft.com/office/powerpoint/2010/main" val="2744916613"/>
       </p:ext>
     </p:extLst>
   </p:cSld>
   <p:clrMapOvr>
     <a:masterClrMapping/>
   </p:clrMapOvr>
+  <p:timing>
+    <p:tnLst>
+      <p:par>
+        <p:cTn id="1" dur="indefinite" restart="never" nodeType="tmRoot">
+          <p:childTnLst>
+            <p:seq concurrent="1" nextAc="seek">
+              <p:cTn id="2" dur="indefinite" nodeType="mainSeq">
+                <p:childTnLst>
+                  <p:par>
+                    <p:cTn id="3" fill="hold">
+                      <p:stCondLst>
+                        <p:cond delay="indefinite"/>
+                      </p:stCondLst>
+                      <p:childTnLst>
+                        <p:par>
+                          <p:cTn id="4" fill="hold">
+                            <p:stCondLst>
+                              <p:cond delay="0"/>
+                            </p:stCondLst>
+                            <p:childTnLst>
+                              <p:par>
+                                <p:cTn id="5" presetID="1" presetClass="entr" presetSubtype="0" fill="hold" grpId="0" nodeType="clickEffect">
+                                  <p:stCondLst>
+                                    <p:cond delay="0"/>
+                                  </p:stCondLst>
+                                  <p:childTnLst>
+                                    <p:set>
+                                      <p:cBhvr>
+                                        <p:cTn id="6" dur="1" fill="hold">
+                                          <p:stCondLst>
+                                            <p:cond delay="0"/>
+                                          </p:stCondLst>
+                                        </p:cTn>
+                                        <p:tgtEl>
+                                          <p:spTgt spid="3">
+                                            <p:txEl>
+                                              <p:pRg st="0" end="0"/>
+                                            </p:txEl>
+                                          </p:spTgt>
+                                        </p:tgtEl>
+                                        <p:attrNameLst>
+                                          <p:attrName>style.visibility</p:attrName>
+                                        </p:attrNameLst>
+                                      </p:cBhvr>
+                                      <p:to>
+                                        <p:strVal val="visible"/>
+                                      </p:to>
+                                    </p:set>
+                                  </p:childTnLst>
+                                </p:cTn>
+                              </p:par>
+                            </p:childTnLst>
+                          </p:cTn>
+                        </p:par>
+                      </p:childTnLst>
+                    </p:cTn>
+                  </p:par>
+                  <p:par>
+                    <p:cTn id="7" fill="hold">
+                      <p:stCondLst>
+                        <p:cond delay="indefinite"/>
+                      </p:stCondLst>
+                      <p:childTnLst>
+                        <p:par>
+                          <p:cTn id="8" fill="hold">
+                            <p:stCondLst>
+                              <p:cond delay="0"/>
+                            </p:stCondLst>
+                            <p:childTnLst>
+                              <p:par>
+                                <p:cTn id="9" presetID="1" presetClass="entr" presetSubtype="0" fill="hold" grpId="0" nodeType="clickEffect">
+                                  <p:stCondLst>
+                                    <p:cond delay="0"/>
+                                  </p:stCondLst>
+                                  <p:childTnLst>
+                                    <p:set>
+                                      <p:cBhvr>
+                                        <p:cTn id="10" dur="1" fill="hold">
+                                          <p:stCondLst>
+                                            <p:cond delay="0"/>
+                                          </p:stCondLst>
+                                        </p:cTn>
+                                        <p:tgtEl>
+                                          <p:spTgt spid="3">
+                                            <p:txEl>
+                                              <p:pRg st="1" end="1"/>
+                                            </p:txEl>
+                                          </p:spTgt>
+                                        </p:tgtEl>
+                                        <p:attrNameLst>
+                                          <p:attrName>style.visibility</p:attrName>
+                                        </p:attrNameLst>
+                                      </p:cBhvr>
+                                      <p:to>
+                                        <p:strVal val="visible"/>
+                                      </p:to>
+                                    </p:set>
+                                  </p:childTnLst>
+                                </p:cTn>
+                              </p:par>
+                            </p:childTnLst>
+                          </p:cTn>
+                        </p:par>
+                      </p:childTnLst>
+                    </p:cTn>
+                  </p:par>
+                  <p:par>
+                    <p:cTn id="11" fill="hold">
+                      <p:stCondLst>
+                        <p:cond delay="indefinite"/>
+                      </p:stCondLst>
+                      <p:childTnLst>
+                        <p:par>
+                          <p:cTn id="12" fill="hold">
+                            <p:stCondLst>
+                              <p:cond delay="0"/>
+                            </p:stCondLst>
+                            <p:childTnLst>
+                              <p:par>
+                                <p:cTn id="13" presetID="1" presetClass="entr" presetSubtype="0" fill="hold" grpId="0" nodeType="clickEffect">
+                                  <p:stCondLst>
+                                    <p:cond delay="0"/>
+                                  </p:stCondLst>
+                                  <p:childTnLst>
+                                    <p:set>
+                                      <p:cBhvr>
+                                        <p:cTn id="14" dur="1" fill="hold">
+                                          <p:stCondLst>
+                                            <p:cond delay="0"/>
+                                          </p:stCondLst>
+                                        </p:cTn>
+                                        <p:tgtEl>
+                                          <p:spTgt spid="7"/>
+                                        </p:tgtEl>
+                                        <p:attrNameLst>
+                                          <p:attrName>style.visibility</p:attrName>
+                                        </p:attrNameLst>
+                                      </p:cBhvr>
+                                      <p:to>
+                                        <p:strVal val="visible"/>
+                                      </p:to>
+                                    </p:set>
+                                  </p:childTnLst>
+                                </p:cTn>
+                              </p:par>
+                            </p:childTnLst>
+                          </p:cTn>
+                        </p:par>
+                      </p:childTnLst>
+                    </p:cTn>
+                  </p:par>
+                  <p:par>
+                    <p:cTn id="15" fill="hold">
+                      <p:stCondLst>
+                        <p:cond delay="indefinite"/>
+                      </p:stCondLst>
+                      <p:childTnLst>
+                        <p:par>
+                          <p:cTn id="16" fill="hold">
+                            <p:stCondLst>
+                              <p:cond delay="0"/>
+                            </p:stCondLst>
+                            <p:childTnLst>
+                              <p:par>
+                                <p:cTn id="17" presetID="1" presetClass="entr" presetSubtype="0" fill="hold" grpId="0" nodeType="clickEffect">
+                                  <p:stCondLst>
+                                    <p:cond delay="0"/>
+                                  </p:stCondLst>
+                                  <p:childTnLst>
+                                    <p:set>
+                                      <p:cBhvr>
+                                        <p:cTn id="18" dur="1" fill="hold">
+                                          <p:stCondLst>
+                                            <p:cond delay="0"/>
+                                          </p:stCondLst>
+                                        </p:cTn>
+                                        <p:tgtEl>
+                                          <p:spTgt spid="3">
+                                            <p:txEl>
+                                              <p:pRg st="4" end="4"/>
+                                            </p:txEl>
+                                          </p:spTgt>
+                                        </p:tgtEl>
+                                        <p:attrNameLst>
+                                          <p:attrName>style.visibility</p:attrName>
+                                        </p:attrNameLst>
+                                      </p:cBhvr>
+                                      <p:to>
+                                        <p:strVal val="visible"/>
+                                      </p:to>
+                                    </p:set>
+                                  </p:childTnLst>
+                                </p:cTn>
+                              </p:par>
+                            </p:childTnLst>
+                          </p:cTn>
+                        </p:par>
+                      </p:childTnLst>
+                    </p:cTn>
+                  </p:par>
+                  <p:par>
+                    <p:cTn id="19" fill="hold">
+                      <p:stCondLst>
+                        <p:cond delay="indefinite"/>
+                      </p:stCondLst>
+                      <p:childTnLst>
+                        <p:par>
+                          <p:cTn id="20" fill="hold">
+                            <p:stCondLst>
+                              <p:cond delay="0"/>
+                            </p:stCondLst>
+                            <p:childTnLst>
+                              <p:par>
+                                <p:cTn id="21" presetID="1" presetClass="entr" presetSubtype="0" fill="hold" grpId="0" nodeType="clickEffect">
+                                  <p:stCondLst>
+                                    <p:cond delay="0"/>
+                                  </p:stCondLst>
+                                  <p:childTnLst>
+                                    <p:set>
+                                      <p:cBhvr>
+                                        <p:cTn id="22" dur="1" fill="hold">
+                                          <p:stCondLst>
+                                            <p:cond delay="0"/>
+                                          </p:stCondLst>
+                                        </p:cTn>
+                                        <p:tgtEl>
+                                          <p:spTgt spid="3">
+                                            <p:txEl>
+                                              <p:pRg st="5" end="5"/>
+                                            </p:txEl>
+                                          </p:spTgt>
+                                        </p:tgtEl>
+                                        <p:attrNameLst>
+                                          <p:attrName>style.visibility</p:attrName>
+                                        </p:attrNameLst>
+                                      </p:cBhvr>
+                                      <p:to>
+                                        <p:strVal val="visible"/>
+                                      </p:to>
+                                    </p:set>
+                                  </p:childTnLst>
+                                </p:cTn>
+                              </p:par>
+                            </p:childTnLst>
+                          </p:cTn>
+                        </p:par>
+                      </p:childTnLst>
+                    </p:cTn>
+                  </p:par>
+                </p:childTnLst>
+              </p:cTn>
+              <p:prevCondLst>
+                <p:cond evt="onPrev" delay="0">
+                  <p:tgtEl>
+                    <p:sldTgt/>
+                  </p:tgtEl>
+                </p:cond>
+              </p:prevCondLst>
+              <p:nextCondLst>
+                <p:cond evt="onNext" delay="0">
+                  <p:tgtEl>
+                    <p:sldTgt/>
+                  </p:tgtEl>
+                </p:cond>
+              </p:nextCondLst>
+            </p:seq>
+          </p:childTnLst>
+        </p:cTn>
+      </p:par>
+    </p:tnLst>
+    <p:bldLst>
+      <p:bldP spid="3" grpId="0" uiExpand="1" build="p"/>
+      <p:bldP spid="7" grpId="0"/>
+    </p:bldLst>
+  </p:timing>
 </p:sld>
 </file>
 
-<file path=ppt/slides/slide3.xml><?xml version="1.0" encoding="utf-8"?>
+<file path=ppt/slides/slide11.xml><?xml version="1.0" encoding="utf-8"?>
+<p:sld xmlns:a="http://schemas.openxmlformats.org/drawingml/2006/main" xmlns:r="http://schemas.openxmlformats.org/officeDocument/2006/relationships" xmlns:p="http://schemas.openxmlformats.org/presentationml/2006/main">
+  <p:cSld>
+    <p:spTree>
+      <p:nvGrpSpPr>
+        <p:cNvPr id="1" name=""/>
+        <p:cNvGrpSpPr/>
+        <p:nvPr/>
+      </p:nvGrpSpPr>
+      <p:grpSpPr>
+        <a:xfrm>
+          <a:off x="0" y="0"/>
+          <a:ext cx="0" cy="0"/>
+          <a:chOff x="0" y="0"/>
+          <a:chExt cx="0" cy="0"/>
+        </a:xfrm>
+      </p:grpSpPr>
+      <p:sp>
+        <p:nvSpPr>
+          <p:cNvPr id="2" name="Title 1">
+            <a:extLst>
+              <a:ext uri="{FF2B5EF4-FFF2-40B4-BE49-F238E27FC236}">
+                <a16:creationId xmlns:a16="http://schemas.microsoft.com/office/drawing/2014/main" id="{D526A964-18EF-DA4C-7AD8-B4E59D925AA9}"/>
+              </a:ext>
+            </a:extLst>
+          </p:cNvPr>
+          <p:cNvSpPr>
+            <a:spLocks noGrp="1"/>
+          </p:cNvSpPr>
+          <p:nvPr>
+            <p:ph type="title"/>
+          </p:nvPr>
+        </p:nvSpPr>
+        <p:spPr/>
+        <p:txBody>
+          <a:bodyPr/>
+          <a:lstStyle/>
+          <a:p>
+            <a:r>
+              <a:rPr lang="en-US" dirty="0"/>
+              <a:t>Out of Order execution</a:t>
+            </a:r>
+            <a:endParaRPr lang="en-IN" dirty="0"/>
+          </a:p>
+        </p:txBody>
+      </p:sp>
+      <p:sp>
+        <p:nvSpPr>
+          <p:cNvPr id="3" name="Content Placeholder 2">
+            <a:extLst>
+              <a:ext uri="{FF2B5EF4-FFF2-40B4-BE49-F238E27FC236}">
+                <a16:creationId xmlns:a16="http://schemas.microsoft.com/office/drawing/2014/main" id="{02912536-9D64-77AF-0F09-1C462B405272}"/>
+              </a:ext>
+            </a:extLst>
+          </p:cNvPr>
+          <p:cNvSpPr>
+            <a:spLocks noGrp="1"/>
+          </p:cNvSpPr>
+          <p:nvPr>
+            <p:ph idx="1"/>
+          </p:nvPr>
+        </p:nvSpPr>
+        <p:spPr/>
+        <p:txBody>
+          <a:bodyPr>
+            <a:normAutofit fontScale="92500"/>
+          </a:bodyPr>
+          <a:lstStyle/>
+          <a:p>
+            <a:r>
+              <a:rPr lang="en-US" dirty="0"/>
+              <a:t>Execute instructions as soon as operands are ready</a:t>
+            </a:r>
+          </a:p>
+          <a:p>
+            <a:pPr lvl="1"/>
+            <a:r>
+              <a:rPr lang="en-US" dirty="0"/>
+              <a:t>Not strictly in program order</a:t>
+            </a:r>
+          </a:p>
+          <a:p>
+            <a:r>
+              <a:rPr lang="en-US" dirty="0"/>
+              <a:t>Results must be committed in correct order</a:t>
+            </a:r>
+          </a:p>
+          <a:p>
+            <a:pPr lvl="1"/>
+            <a:r>
+              <a:rPr lang="en-US" dirty="0"/>
+              <a:t>Writeback to </a:t>
+            </a:r>
+            <a:r>
+              <a:rPr lang="en-US" dirty="0" err="1"/>
+              <a:t>RegFile</a:t>
+            </a:r>
+            <a:r>
+              <a:rPr lang="en-US" dirty="0"/>
+              <a:t>, memory writes must not violate instruction ordering</a:t>
+            </a:r>
+          </a:p>
+          <a:p>
+            <a:pPr lvl="1"/>
+            <a:r>
+              <a:rPr lang="en-IN" dirty="0">
+                <a:solidFill>
+                  <a:srgbClr val="FF0000"/>
+                </a:solidFill>
+              </a:rPr>
+              <a:t>Is this necessary if instructions are independent?</a:t>
+            </a:r>
+          </a:p>
+          <a:p>
+            <a:r>
+              <a:rPr lang="en-IN" dirty="0"/>
+              <a:t>What can go wrong if commits are not in order?</a:t>
+            </a:r>
+          </a:p>
+          <a:p>
+            <a:pPr lvl="1"/>
+            <a:r>
+              <a:rPr lang="en-IN" dirty="0"/>
+              <a:t>Exceptions</a:t>
+            </a:r>
+          </a:p>
+          <a:p>
+            <a:pPr lvl="1"/>
+            <a:r>
+              <a:rPr lang="en-IN" dirty="0"/>
+              <a:t>Memory operations (load / store from same location)</a:t>
+            </a:r>
+          </a:p>
+          <a:p>
+            <a:pPr lvl="1"/>
+            <a:r>
+              <a:rPr lang="en-IN" dirty="0" err="1"/>
+              <a:t>Syscalls</a:t>
+            </a:r>
+            <a:r>
+              <a:rPr lang="en-IN" dirty="0"/>
+              <a:t>, memory mapped I/O, interrupts</a:t>
+            </a:r>
+          </a:p>
+        </p:txBody>
+      </p:sp>
+      <p:sp>
+        <p:nvSpPr>
+          <p:cNvPr id="4" name="Date Placeholder 3">
+            <a:extLst>
+              <a:ext uri="{FF2B5EF4-FFF2-40B4-BE49-F238E27FC236}">
+                <a16:creationId xmlns:a16="http://schemas.microsoft.com/office/drawing/2014/main" id="{3F63AE59-9E90-7D6E-17B1-012990D0E17D}"/>
+              </a:ext>
+            </a:extLst>
+          </p:cNvPr>
+          <p:cNvSpPr>
+            <a:spLocks noGrp="1"/>
+          </p:cNvSpPr>
+          <p:nvPr>
+            <p:ph type="dt" sz="half" idx="10"/>
+          </p:nvPr>
+        </p:nvSpPr>
+        <p:spPr/>
+        <p:txBody>
+          <a:bodyPr/>
+          <a:lstStyle/>
+          <a:p>
+            <a:pPr>
+              <a:defRPr/>
+            </a:pPr>
+            <a:r>
+              <a:rPr lang="en-US"/>
+              <a:t>21/12/2020</a:t>
+            </a:r>
+          </a:p>
+        </p:txBody>
+      </p:sp>
+      <p:sp>
+        <p:nvSpPr>
+          <p:cNvPr id="5" name="Slide Number Placeholder 4">
+            <a:extLst>
+              <a:ext uri="{FF2B5EF4-FFF2-40B4-BE49-F238E27FC236}">
+                <a16:creationId xmlns:a16="http://schemas.microsoft.com/office/drawing/2014/main" id="{BBD33F29-33B7-910C-8BE6-FB96C84F538C}"/>
+              </a:ext>
+            </a:extLst>
+          </p:cNvPr>
+          <p:cNvSpPr>
+            <a:spLocks noGrp="1"/>
+          </p:cNvSpPr>
+          <p:nvPr>
+            <p:ph type="sldNum" sz="quarter" idx="12"/>
+          </p:nvPr>
+        </p:nvSpPr>
+        <p:spPr/>
+        <p:txBody>
+          <a:bodyPr/>
+          <a:lstStyle/>
+          <a:p>
+            <a:pPr>
+              <a:defRPr/>
+            </a:pPr>
+            <a:fld id="{CA887A73-1AE0-46F8-856A-18EA1CF30A1B}" type="slidenum">
+              <a:rPr lang="en-US" altLang="en-US" smtClean="0"/>
+              <a:pPr>
+                <a:defRPr/>
+              </a:pPr>
+              <a:t>11</a:t>
+            </a:fld>
+            <a:endParaRPr lang="en-US" altLang="en-US"/>
+          </a:p>
+        </p:txBody>
+      </p:sp>
+    </p:spTree>
+    <p:extLst>
+      <p:ext uri="{BB962C8B-B14F-4D97-AF65-F5344CB8AC3E}">
+        <p14:creationId xmlns:p14="http://schemas.microsoft.com/office/powerpoint/2010/main" val="761471436"/>
+      </p:ext>
+    </p:extLst>
+  </p:cSld>
+  <p:clrMapOvr>
+    <a:masterClrMapping/>
+  </p:clrMapOvr>
+  <p:timing>
+    <p:tnLst>
+      <p:par>
+        <p:cTn id="1" dur="indefinite" restart="never" nodeType="tmRoot">
+          <p:childTnLst>
+            <p:seq concurrent="1" nextAc="seek">
+              <p:cTn id="2" dur="indefinite" nodeType="mainSeq">
+                <p:childTnLst>
+                  <p:par>
+                    <p:cTn id="3" fill="hold">
+                      <p:stCondLst>
+                        <p:cond delay="indefinite"/>
+                      </p:stCondLst>
+                      <p:childTnLst>
+                        <p:par>
+                          <p:cTn id="4" fill="hold">
+                            <p:stCondLst>
+                              <p:cond delay="0"/>
+                            </p:stCondLst>
+                            <p:childTnLst>
+                              <p:par>
+                                <p:cTn id="5" presetID="1" presetClass="entr" presetSubtype="0" fill="hold" grpId="0" nodeType="clickEffect">
+                                  <p:stCondLst>
+                                    <p:cond delay="0"/>
+                                  </p:stCondLst>
+                                  <p:childTnLst>
+                                    <p:set>
+                                      <p:cBhvr>
+                                        <p:cTn id="6" dur="1" fill="hold">
+                                          <p:stCondLst>
+                                            <p:cond delay="0"/>
+                                          </p:stCondLst>
+                                        </p:cTn>
+                                        <p:tgtEl>
+                                          <p:spTgt spid="3">
+                                            <p:txEl>
+                                              <p:pRg st="0" end="0"/>
+                                            </p:txEl>
+                                          </p:spTgt>
+                                        </p:tgtEl>
+                                        <p:attrNameLst>
+                                          <p:attrName>style.visibility</p:attrName>
+                                        </p:attrNameLst>
+                                      </p:cBhvr>
+                                      <p:to>
+                                        <p:strVal val="visible"/>
+                                      </p:to>
+                                    </p:set>
+                                  </p:childTnLst>
+                                </p:cTn>
+                              </p:par>
+                            </p:childTnLst>
+                          </p:cTn>
+                        </p:par>
+                      </p:childTnLst>
+                    </p:cTn>
+                  </p:par>
+                  <p:par>
+                    <p:cTn id="7" fill="hold">
+                      <p:stCondLst>
+                        <p:cond delay="indefinite"/>
+                      </p:stCondLst>
+                      <p:childTnLst>
+                        <p:par>
+                          <p:cTn id="8" fill="hold">
+                            <p:stCondLst>
+                              <p:cond delay="0"/>
+                            </p:stCondLst>
+                            <p:childTnLst>
+                              <p:par>
+                                <p:cTn id="9" presetID="1" presetClass="entr" presetSubtype="0" fill="hold" grpId="0" nodeType="clickEffect">
+                                  <p:stCondLst>
+                                    <p:cond delay="0"/>
+                                  </p:stCondLst>
+                                  <p:childTnLst>
+                                    <p:set>
+                                      <p:cBhvr>
+                                        <p:cTn id="10" dur="1" fill="hold">
+                                          <p:stCondLst>
+                                            <p:cond delay="0"/>
+                                          </p:stCondLst>
+                                        </p:cTn>
+                                        <p:tgtEl>
+                                          <p:spTgt spid="3">
+                                            <p:txEl>
+                                              <p:pRg st="1" end="1"/>
+                                            </p:txEl>
+                                          </p:spTgt>
+                                        </p:tgtEl>
+                                        <p:attrNameLst>
+                                          <p:attrName>style.visibility</p:attrName>
+                                        </p:attrNameLst>
+                                      </p:cBhvr>
+                                      <p:to>
+                                        <p:strVal val="visible"/>
+                                      </p:to>
+                                    </p:set>
+                                  </p:childTnLst>
+                                </p:cTn>
+                              </p:par>
+                            </p:childTnLst>
+                          </p:cTn>
+                        </p:par>
+                      </p:childTnLst>
+                    </p:cTn>
+                  </p:par>
+                  <p:par>
+                    <p:cTn id="11" fill="hold">
+                      <p:stCondLst>
+                        <p:cond delay="indefinite"/>
+                      </p:stCondLst>
+                      <p:childTnLst>
+                        <p:par>
+                          <p:cTn id="12" fill="hold">
+                            <p:stCondLst>
+                              <p:cond delay="0"/>
+                            </p:stCondLst>
+                            <p:childTnLst>
+                              <p:par>
+                                <p:cTn id="13" presetID="1" presetClass="entr" presetSubtype="0" fill="hold" grpId="0" nodeType="clickEffect">
+                                  <p:stCondLst>
+                                    <p:cond delay="0"/>
+                                  </p:stCondLst>
+                                  <p:childTnLst>
+                                    <p:set>
+                                      <p:cBhvr>
+                                        <p:cTn id="14" dur="1" fill="hold">
+                                          <p:stCondLst>
+                                            <p:cond delay="0"/>
+                                          </p:stCondLst>
+                                        </p:cTn>
+                                        <p:tgtEl>
+                                          <p:spTgt spid="3">
+                                            <p:txEl>
+                                              <p:pRg st="2" end="2"/>
+                                            </p:txEl>
+                                          </p:spTgt>
+                                        </p:tgtEl>
+                                        <p:attrNameLst>
+                                          <p:attrName>style.visibility</p:attrName>
+                                        </p:attrNameLst>
+                                      </p:cBhvr>
+                                      <p:to>
+                                        <p:strVal val="visible"/>
+                                      </p:to>
+                                    </p:set>
+                                  </p:childTnLst>
+                                </p:cTn>
+                              </p:par>
+                            </p:childTnLst>
+                          </p:cTn>
+                        </p:par>
+                      </p:childTnLst>
+                    </p:cTn>
+                  </p:par>
+                  <p:par>
+                    <p:cTn id="15" fill="hold">
+                      <p:stCondLst>
+                        <p:cond delay="indefinite"/>
+                      </p:stCondLst>
+                      <p:childTnLst>
+                        <p:par>
+                          <p:cTn id="16" fill="hold">
+                            <p:stCondLst>
+                              <p:cond delay="0"/>
+                            </p:stCondLst>
+                            <p:childTnLst>
+                              <p:par>
+                                <p:cTn id="17" presetID="1" presetClass="entr" presetSubtype="0" fill="hold" grpId="0" nodeType="clickEffect">
+                                  <p:stCondLst>
+                                    <p:cond delay="0"/>
+                                  </p:stCondLst>
+                                  <p:childTnLst>
+                                    <p:set>
+                                      <p:cBhvr>
+                                        <p:cTn id="18" dur="1" fill="hold">
+                                          <p:stCondLst>
+                                            <p:cond delay="0"/>
+                                          </p:stCondLst>
+                                        </p:cTn>
+                                        <p:tgtEl>
+                                          <p:spTgt spid="3">
+                                            <p:txEl>
+                                              <p:pRg st="3" end="3"/>
+                                            </p:txEl>
+                                          </p:spTgt>
+                                        </p:tgtEl>
+                                        <p:attrNameLst>
+                                          <p:attrName>style.visibility</p:attrName>
+                                        </p:attrNameLst>
+                                      </p:cBhvr>
+                                      <p:to>
+                                        <p:strVal val="visible"/>
+                                      </p:to>
+                                    </p:set>
+                                  </p:childTnLst>
+                                </p:cTn>
+                              </p:par>
+                            </p:childTnLst>
+                          </p:cTn>
+                        </p:par>
+                      </p:childTnLst>
+                    </p:cTn>
+                  </p:par>
+                  <p:par>
+                    <p:cTn id="19" fill="hold">
+                      <p:stCondLst>
+                        <p:cond delay="indefinite"/>
+                      </p:stCondLst>
+                      <p:childTnLst>
+                        <p:par>
+                          <p:cTn id="20" fill="hold">
+                            <p:stCondLst>
+                              <p:cond delay="0"/>
+                            </p:stCondLst>
+                            <p:childTnLst>
+                              <p:par>
+                                <p:cTn id="21" presetID="1" presetClass="entr" presetSubtype="0" fill="hold" grpId="0" nodeType="clickEffect">
+                                  <p:stCondLst>
+                                    <p:cond delay="0"/>
+                                  </p:stCondLst>
+                                  <p:childTnLst>
+                                    <p:set>
+                                      <p:cBhvr>
+                                        <p:cTn id="22" dur="1" fill="hold">
+                                          <p:stCondLst>
+                                            <p:cond delay="0"/>
+                                          </p:stCondLst>
+                                        </p:cTn>
+                                        <p:tgtEl>
+                                          <p:spTgt spid="3">
+                                            <p:txEl>
+                                              <p:pRg st="4" end="4"/>
+                                            </p:txEl>
+                                          </p:spTgt>
+                                        </p:tgtEl>
+                                        <p:attrNameLst>
+                                          <p:attrName>style.visibility</p:attrName>
+                                        </p:attrNameLst>
+                                      </p:cBhvr>
+                                      <p:to>
+                                        <p:strVal val="visible"/>
+                                      </p:to>
+                                    </p:set>
+                                  </p:childTnLst>
+                                </p:cTn>
+                              </p:par>
+                            </p:childTnLst>
+                          </p:cTn>
+                        </p:par>
+                      </p:childTnLst>
+                    </p:cTn>
+                  </p:par>
+                  <p:par>
+                    <p:cTn id="23" fill="hold">
+                      <p:stCondLst>
+                        <p:cond delay="indefinite"/>
+                      </p:stCondLst>
+                      <p:childTnLst>
+                        <p:par>
+                          <p:cTn id="24" fill="hold">
+                            <p:stCondLst>
+                              <p:cond delay="0"/>
+                            </p:stCondLst>
+                            <p:childTnLst>
+                              <p:par>
+                                <p:cTn id="25" presetID="1" presetClass="entr" presetSubtype="0" fill="hold" grpId="0" nodeType="clickEffect">
+                                  <p:stCondLst>
+                                    <p:cond delay="0"/>
+                                  </p:stCondLst>
+                                  <p:childTnLst>
+                                    <p:set>
+                                      <p:cBhvr>
+                                        <p:cTn id="26" dur="1" fill="hold">
+                                          <p:stCondLst>
+                                            <p:cond delay="0"/>
+                                          </p:stCondLst>
+                                        </p:cTn>
+                                        <p:tgtEl>
+                                          <p:spTgt spid="3">
+                                            <p:txEl>
+                                              <p:pRg st="5" end="5"/>
+                                            </p:txEl>
+                                          </p:spTgt>
+                                        </p:tgtEl>
+                                        <p:attrNameLst>
+                                          <p:attrName>style.visibility</p:attrName>
+                                        </p:attrNameLst>
+                                      </p:cBhvr>
+                                      <p:to>
+                                        <p:strVal val="visible"/>
+                                      </p:to>
+                                    </p:set>
+                                  </p:childTnLst>
+                                </p:cTn>
+                              </p:par>
+                            </p:childTnLst>
+                          </p:cTn>
+                        </p:par>
+                      </p:childTnLst>
+                    </p:cTn>
+                  </p:par>
+                  <p:par>
+                    <p:cTn id="27" fill="hold">
+                      <p:stCondLst>
+                        <p:cond delay="indefinite"/>
+                      </p:stCondLst>
+                      <p:childTnLst>
+                        <p:par>
+                          <p:cTn id="28" fill="hold">
+                            <p:stCondLst>
+                              <p:cond delay="0"/>
+                            </p:stCondLst>
+                            <p:childTnLst>
+                              <p:par>
+                                <p:cTn id="29" presetID="1" presetClass="entr" presetSubtype="0" fill="hold" grpId="0" nodeType="clickEffect">
+                                  <p:stCondLst>
+                                    <p:cond delay="0"/>
+                                  </p:stCondLst>
+                                  <p:childTnLst>
+                                    <p:set>
+                                      <p:cBhvr>
+                                        <p:cTn id="30" dur="1" fill="hold">
+                                          <p:stCondLst>
+                                            <p:cond delay="0"/>
+                                          </p:stCondLst>
+                                        </p:cTn>
+                                        <p:tgtEl>
+                                          <p:spTgt spid="3">
+                                            <p:txEl>
+                                              <p:pRg st="6" end="6"/>
+                                            </p:txEl>
+                                          </p:spTgt>
+                                        </p:tgtEl>
+                                        <p:attrNameLst>
+                                          <p:attrName>style.visibility</p:attrName>
+                                        </p:attrNameLst>
+                                      </p:cBhvr>
+                                      <p:to>
+                                        <p:strVal val="visible"/>
+                                      </p:to>
+                                    </p:set>
+                                  </p:childTnLst>
+                                </p:cTn>
+                              </p:par>
+                            </p:childTnLst>
+                          </p:cTn>
+                        </p:par>
+                      </p:childTnLst>
+                    </p:cTn>
+                  </p:par>
+                  <p:par>
+                    <p:cTn id="31" fill="hold">
+                      <p:stCondLst>
+                        <p:cond delay="indefinite"/>
+                      </p:stCondLst>
+                      <p:childTnLst>
+                        <p:par>
+                          <p:cTn id="32" fill="hold">
+                            <p:stCondLst>
+                              <p:cond delay="0"/>
+                            </p:stCondLst>
+                            <p:childTnLst>
+                              <p:par>
+                                <p:cTn id="33" presetID="1" presetClass="entr" presetSubtype="0" fill="hold" grpId="0" nodeType="clickEffect">
+                                  <p:stCondLst>
+                                    <p:cond delay="0"/>
+                                  </p:stCondLst>
+                                  <p:childTnLst>
+                                    <p:set>
+                                      <p:cBhvr>
+                                        <p:cTn id="34" dur="1" fill="hold">
+                                          <p:stCondLst>
+                                            <p:cond delay="0"/>
+                                          </p:stCondLst>
+                                        </p:cTn>
+                                        <p:tgtEl>
+                                          <p:spTgt spid="3">
+                                            <p:txEl>
+                                              <p:pRg st="7" end="7"/>
+                                            </p:txEl>
+                                          </p:spTgt>
+                                        </p:tgtEl>
+                                        <p:attrNameLst>
+                                          <p:attrName>style.visibility</p:attrName>
+                                        </p:attrNameLst>
+                                      </p:cBhvr>
+                                      <p:to>
+                                        <p:strVal val="visible"/>
+                                      </p:to>
+                                    </p:set>
+                                  </p:childTnLst>
+                                </p:cTn>
+                              </p:par>
+                            </p:childTnLst>
+                          </p:cTn>
+                        </p:par>
+                      </p:childTnLst>
+                    </p:cTn>
+                  </p:par>
+                  <p:par>
+                    <p:cTn id="35" fill="hold">
+                      <p:stCondLst>
+                        <p:cond delay="indefinite"/>
+                      </p:stCondLst>
+                      <p:childTnLst>
+                        <p:par>
+                          <p:cTn id="36" fill="hold">
+                            <p:stCondLst>
+                              <p:cond delay="0"/>
+                            </p:stCondLst>
+                            <p:childTnLst>
+                              <p:par>
+                                <p:cTn id="37" presetID="1" presetClass="entr" presetSubtype="0" fill="hold" grpId="0" nodeType="clickEffect">
+                                  <p:stCondLst>
+                                    <p:cond delay="0"/>
+                                  </p:stCondLst>
+                                  <p:childTnLst>
+                                    <p:set>
+                                      <p:cBhvr>
+                                        <p:cTn id="38" dur="1" fill="hold">
+                                          <p:stCondLst>
+                                            <p:cond delay="0"/>
+                                          </p:stCondLst>
+                                        </p:cTn>
+                                        <p:tgtEl>
+                                          <p:spTgt spid="3">
+                                            <p:txEl>
+                                              <p:pRg st="8" end="8"/>
+                                            </p:txEl>
+                                          </p:spTgt>
+                                        </p:tgtEl>
+                                        <p:attrNameLst>
+                                          <p:attrName>style.visibility</p:attrName>
+                                        </p:attrNameLst>
+                                      </p:cBhvr>
+                                      <p:to>
+                                        <p:strVal val="visible"/>
+                                      </p:to>
+                                    </p:set>
+                                  </p:childTnLst>
+                                </p:cTn>
+                              </p:par>
+                            </p:childTnLst>
+                          </p:cTn>
+                        </p:par>
+                      </p:childTnLst>
+                    </p:cTn>
+                  </p:par>
+                </p:childTnLst>
+              </p:cTn>
+              <p:prevCondLst>
+                <p:cond evt="onPrev" delay="0">
+                  <p:tgtEl>
+                    <p:sldTgt/>
+                  </p:tgtEl>
+                </p:cond>
+              </p:prevCondLst>
+              <p:nextCondLst>
+                <p:cond evt="onNext" delay="0">
+                  <p:tgtEl>
+                    <p:sldTgt/>
+                  </p:tgtEl>
+                </p:cond>
+              </p:nextCondLst>
+            </p:seq>
+          </p:childTnLst>
+        </p:cTn>
+      </p:par>
+    </p:tnLst>
+    <p:bldLst>
+      <p:bldP spid="3" grpId="0" build="p"/>
+    </p:bldLst>
+  </p:timing>
+</p:sld>
+</file>
+
+<file path=ppt/slides/slide12.xml><?xml version="1.0" encoding="utf-8"?>
+<p:sld xmlns:a="http://schemas.openxmlformats.org/drawingml/2006/main" xmlns:r="http://schemas.openxmlformats.org/officeDocument/2006/relationships" xmlns:p="http://schemas.openxmlformats.org/presentationml/2006/main">
+  <p:cSld>
+    <p:spTree>
+      <p:nvGrpSpPr>
+        <p:cNvPr id="1" name=""/>
+        <p:cNvGrpSpPr/>
+        <p:nvPr/>
+      </p:nvGrpSpPr>
+      <p:grpSpPr>
+        <a:xfrm>
+          <a:off x="0" y="0"/>
+          <a:ext cx="0" cy="0"/>
+          <a:chOff x="0" y="0"/>
+          <a:chExt cx="0" cy="0"/>
+        </a:xfrm>
+      </p:grpSpPr>
+      <p:pic>
+        <p:nvPicPr>
+          <p:cNvPr id="8" name="Picture 7">
+            <a:extLst>
+              <a:ext uri="{FF2B5EF4-FFF2-40B4-BE49-F238E27FC236}">
+                <a16:creationId xmlns:a16="http://schemas.microsoft.com/office/drawing/2014/main" id="{C8F9BD40-F573-44C9-115C-5F880AFCFDF0}"/>
+              </a:ext>
+            </a:extLst>
+          </p:cNvPr>
+          <p:cNvPicPr>
+            <a:picLocks noChangeAspect="1"/>
+          </p:cNvPicPr>
+          <p:nvPr/>
+        </p:nvPicPr>
+        <p:blipFill>
+          <a:blip r:embed="rId2"/>
+          <a:stretch>
+            <a:fillRect/>
+          </a:stretch>
+        </p:blipFill>
+        <p:spPr>
+          <a:xfrm>
+            <a:off x="3733800" y="1371599"/>
+            <a:ext cx="5377543" cy="3577457"/>
+          </a:xfrm>
+          <a:prstGeom prst="rect">
+            <a:avLst/>
+          </a:prstGeom>
+        </p:spPr>
+      </p:pic>
+      <p:sp>
+        <p:nvSpPr>
+          <p:cNvPr id="2" name="Title 1">
+            <a:extLst>
+              <a:ext uri="{FF2B5EF4-FFF2-40B4-BE49-F238E27FC236}">
+                <a16:creationId xmlns:a16="http://schemas.microsoft.com/office/drawing/2014/main" id="{B2990773-F0F7-F027-120C-076E01D6A2F2}"/>
+              </a:ext>
+            </a:extLst>
+          </p:cNvPr>
+          <p:cNvSpPr>
+            <a:spLocks noGrp="1"/>
+          </p:cNvSpPr>
+          <p:nvPr>
+            <p:ph type="title"/>
+          </p:nvPr>
+        </p:nvSpPr>
+        <p:spPr/>
+        <p:txBody>
+          <a:bodyPr/>
+          <a:lstStyle/>
+          <a:p>
+            <a:r>
+              <a:rPr lang="en-US" dirty="0"/>
+              <a:t>How it works</a:t>
+            </a:r>
+            <a:endParaRPr lang="en-IN" dirty="0"/>
+          </a:p>
+        </p:txBody>
+      </p:sp>
+      <p:sp>
+        <p:nvSpPr>
+          <p:cNvPr id="3" name="Content Placeholder 2">
+            <a:extLst>
+              <a:ext uri="{FF2B5EF4-FFF2-40B4-BE49-F238E27FC236}">
+                <a16:creationId xmlns:a16="http://schemas.microsoft.com/office/drawing/2014/main" id="{DCDB1FA2-72C2-9E24-BB0D-B926C0BC9A7B}"/>
+              </a:ext>
+            </a:extLst>
+          </p:cNvPr>
+          <p:cNvSpPr>
+            <a:spLocks noGrp="1"/>
+          </p:cNvSpPr>
+          <p:nvPr>
+            <p:ph idx="1"/>
+          </p:nvPr>
+        </p:nvSpPr>
+        <p:spPr>
+          <a:xfrm>
+            <a:off x="152400" y="1446211"/>
+            <a:ext cx="4343400" cy="5014912"/>
+          </a:xfrm>
+        </p:spPr>
+        <p:txBody>
+          <a:bodyPr>
+            <a:normAutofit fontScale="77500" lnSpcReduction="20000"/>
+          </a:bodyPr>
+          <a:lstStyle/>
+          <a:p>
+            <a:r>
+              <a:rPr lang="en-US" dirty="0"/>
+              <a:t>Reservation stations: Hold instructions waiting for execution</a:t>
+            </a:r>
+          </a:p>
+          <a:p>
+            <a:r>
+              <a:rPr lang="en-US" dirty="0"/>
+              <a:t>Reorder buffers: circular buffers that hold completed instruction results</a:t>
+            </a:r>
+          </a:p>
+          <a:p>
+            <a:pPr lvl="1"/>
+            <a:r>
+              <a:rPr lang="en-US" dirty="0"/>
+              <a:t>Each new instruction dispatched gets a slot in the tail of the buffer</a:t>
+            </a:r>
+          </a:p>
+          <a:p>
+            <a:pPr lvl="1"/>
+            <a:r>
+              <a:rPr lang="en-US" dirty="0"/>
+              <a:t>When the earliest instruction still waiting is complete, it is committed, moving the buffer forward</a:t>
+            </a:r>
+          </a:p>
+          <a:p>
+            <a:r>
+              <a:rPr lang="en-US" dirty="0"/>
+              <a:t>Register renaming</a:t>
+            </a:r>
+          </a:p>
+          <a:p>
+            <a:r>
+              <a:rPr lang="en-US" dirty="0"/>
+              <a:t>Speculative execution</a:t>
+            </a:r>
+            <a:endParaRPr lang="en-IN" dirty="0"/>
+          </a:p>
+        </p:txBody>
+      </p:sp>
+      <p:sp>
+        <p:nvSpPr>
+          <p:cNvPr id="4" name="Date Placeholder 3">
+            <a:extLst>
+              <a:ext uri="{FF2B5EF4-FFF2-40B4-BE49-F238E27FC236}">
+                <a16:creationId xmlns:a16="http://schemas.microsoft.com/office/drawing/2014/main" id="{DFC83F96-61CE-FE8E-1AD8-DA9FF4274FC3}"/>
+              </a:ext>
+            </a:extLst>
+          </p:cNvPr>
+          <p:cNvSpPr>
+            <a:spLocks noGrp="1"/>
+          </p:cNvSpPr>
+          <p:nvPr>
+            <p:ph type="dt" sz="half" idx="10"/>
+          </p:nvPr>
+        </p:nvSpPr>
+        <p:spPr/>
+        <p:txBody>
+          <a:bodyPr/>
+          <a:lstStyle/>
+          <a:p>
+            <a:pPr>
+              <a:defRPr/>
+            </a:pPr>
+            <a:r>
+              <a:rPr lang="en-US"/>
+              <a:t>21/12/2020</a:t>
+            </a:r>
+          </a:p>
+        </p:txBody>
+      </p:sp>
+      <p:sp>
+        <p:nvSpPr>
+          <p:cNvPr id="5" name="Slide Number Placeholder 4">
+            <a:extLst>
+              <a:ext uri="{FF2B5EF4-FFF2-40B4-BE49-F238E27FC236}">
+                <a16:creationId xmlns:a16="http://schemas.microsoft.com/office/drawing/2014/main" id="{33FC41E0-A189-6DD9-7B25-323F61C48E67}"/>
+              </a:ext>
+            </a:extLst>
+          </p:cNvPr>
+          <p:cNvSpPr>
+            <a:spLocks noGrp="1"/>
+          </p:cNvSpPr>
+          <p:nvPr>
+            <p:ph type="sldNum" sz="quarter" idx="12"/>
+          </p:nvPr>
+        </p:nvSpPr>
+        <p:spPr/>
+        <p:txBody>
+          <a:bodyPr/>
+          <a:lstStyle/>
+          <a:p>
+            <a:pPr>
+              <a:defRPr/>
+            </a:pPr>
+            <a:fld id="{CA887A73-1AE0-46F8-856A-18EA1CF30A1B}" type="slidenum">
+              <a:rPr lang="en-US" altLang="en-US" smtClean="0"/>
+              <a:pPr>
+                <a:defRPr/>
+              </a:pPr>
+              <a:t>12</a:t>
+            </a:fld>
+            <a:endParaRPr lang="en-US" altLang="en-US"/>
+          </a:p>
+        </p:txBody>
+      </p:sp>
+    </p:spTree>
+    <p:extLst>
+      <p:ext uri="{BB962C8B-B14F-4D97-AF65-F5344CB8AC3E}">
+        <p14:creationId xmlns:p14="http://schemas.microsoft.com/office/powerpoint/2010/main" val="1658738625"/>
+      </p:ext>
+    </p:extLst>
+  </p:cSld>
+  <p:clrMapOvr>
+    <a:masterClrMapping/>
+  </p:clrMapOvr>
+  <p:timing>
+    <p:tnLst>
+      <p:par>
+        <p:cTn id="1" dur="indefinite" restart="never" nodeType="tmRoot">
+          <p:childTnLst>
+            <p:seq concurrent="1" nextAc="seek">
+              <p:cTn id="2" dur="indefinite" nodeType="mainSeq">
+                <p:childTnLst>
+                  <p:par>
+                    <p:cTn id="3" fill="hold">
+                      <p:stCondLst>
+                        <p:cond delay="indefinite"/>
+                      </p:stCondLst>
+                      <p:childTnLst>
+                        <p:par>
+                          <p:cTn id="4" fill="hold">
+                            <p:stCondLst>
+                              <p:cond delay="0"/>
+                            </p:stCondLst>
+                            <p:childTnLst>
+                              <p:par>
+                                <p:cTn id="5" presetID="1" presetClass="entr" presetSubtype="0" fill="hold" grpId="0" nodeType="clickEffect">
+                                  <p:stCondLst>
+                                    <p:cond delay="0"/>
+                                  </p:stCondLst>
+                                  <p:childTnLst>
+                                    <p:set>
+                                      <p:cBhvr>
+                                        <p:cTn id="6" dur="1" fill="hold">
+                                          <p:stCondLst>
+                                            <p:cond delay="0"/>
+                                          </p:stCondLst>
+                                        </p:cTn>
+                                        <p:tgtEl>
+                                          <p:spTgt spid="3">
+                                            <p:txEl>
+                                              <p:pRg st="0" end="0"/>
+                                            </p:txEl>
+                                          </p:spTgt>
+                                        </p:tgtEl>
+                                        <p:attrNameLst>
+                                          <p:attrName>style.visibility</p:attrName>
+                                        </p:attrNameLst>
+                                      </p:cBhvr>
+                                      <p:to>
+                                        <p:strVal val="visible"/>
+                                      </p:to>
+                                    </p:set>
+                                  </p:childTnLst>
+                                </p:cTn>
+                              </p:par>
+                            </p:childTnLst>
+                          </p:cTn>
+                        </p:par>
+                      </p:childTnLst>
+                    </p:cTn>
+                  </p:par>
+                  <p:par>
+                    <p:cTn id="7" fill="hold">
+                      <p:stCondLst>
+                        <p:cond delay="indefinite"/>
+                      </p:stCondLst>
+                      <p:childTnLst>
+                        <p:par>
+                          <p:cTn id="8" fill="hold">
+                            <p:stCondLst>
+                              <p:cond delay="0"/>
+                            </p:stCondLst>
+                            <p:childTnLst>
+                              <p:par>
+                                <p:cTn id="9" presetID="1" presetClass="entr" presetSubtype="0" fill="hold" grpId="0" nodeType="clickEffect">
+                                  <p:stCondLst>
+                                    <p:cond delay="0"/>
+                                  </p:stCondLst>
+                                  <p:childTnLst>
+                                    <p:set>
+                                      <p:cBhvr>
+                                        <p:cTn id="10" dur="1" fill="hold">
+                                          <p:stCondLst>
+                                            <p:cond delay="0"/>
+                                          </p:stCondLst>
+                                        </p:cTn>
+                                        <p:tgtEl>
+                                          <p:spTgt spid="3">
+                                            <p:txEl>
+                                              <p:pRg st="1" end="1"/>
+                                            </p:txEl>
+                                          </p:spTgt>
+                                        </p:tgtEl>
+                                        <p:attrNameLst>
+                                          <p:attrName>style.visibility</p:attrName>
+                                        </p:attrNameLst>
+                                      </p:cBhvr>
+                                      <p:to>
+                                        <p:strVal val="visible"/>
+                                      </p:to>
+                                    </p:set>
+                                  </p:childTnLst>
+                                </p:cTn>
+                              </p:par>
+                            </p:childTnLst>
+                          </p:cTn>
+                        </p:par>
+                      </p:childTnLst>
+                    </p:cTn>
+                  </p:par>
+                  <p:par>
+                    <p:cTn id="11" fill="hold">
+                      <p:stCondLst>
+                        <p:cond delay="indefinite"/>
+                      </p:stCondLst>
+                      <p:childTnLst>
+                        <p:par>
+                          <p:cTn id="12" fill="hold">
+                            <p:stCondLst>
+                              <p:cond delay="0"/>
+                            </p:stCondLst>
+                            <p:childTnLst>
+                              <p:par>
+                                <p:cTn id="13" presetID="1" presetClass="entr" presetSubtype="0" fill="hold" grpId="0" nodeType="clickEffect">
+                                  <p:stCondLst>
+                                    <p:cond delay="0"/>
+                                  </p:stCondLst>
+                                  <p:childTnLst>
+                                    <p:set>
+                                      <p:cBhvr>
+                                        <p:cTn id="14" dur="1" fill="hold">
+                                          <p:stCondLst>
+                                            <p:cond delay="0"/>
+                                          </p:stCondLst>
+                                        </p:cTn>
+                                        <p:tgtEl>
+                                          <p:spTgt spid="3">
+                                            <p:txEl>
+                                              <p:pRg st="2" end="2"/>
+                                            </p:txEl>
+                                          </p:spTgt>
+                                        </p:tgtEl>
+                                        <p:attrNameLst>
+                                          <p:attrName>style.visibility</p:attrName>
+                                        </p:attrNameLst>
+                                      </p:cBhvr>
+                                      <p:to>
+                                        <p:strVal val="visible"/>
+                                      </p:to>
+                                    </p:set>
+                                  </p:childTnLst>
+                                </p:cTn>
+                              </p:par>
+                            </p:childTnLst>
+                          </p:cTn>
+                        </p:par>
+                      </p:childTnLst>
+                    </p:cTn>
+                  </p:par>
+                  <p:par>
+                    <p:cTn id="15" fill="hold">
+                      <p:stCondLst>
+                        <p:cond delay="indefinite"/>
+                      </p:stCondLst>
+                      <p:childTnLst>
+                        <p:par>
+                          <p:cTn id="16" fill="hold">
+                            <p:stCondLst>
+                              <p:cond delay="0"/>
+                            </p:stCondLst>
+                            <p:childTnLst>
+                              <p:par>
+                                <p:cTn id="17" presetID="1" presetClass="entr" presetSubtype="0" fill="hold" grpId="0" nodeType="clickEffect">
+                                  <p:stCondLst>
+                                    <p:cond delay="0"/>
+                                  </p:stCondLst>
+                                  <p:childTnLst>
+                                    <p:set>
+                                      <p:cBhvr>
+                                        <p:cTn id="18" dur="1" fill="hold">
+                                          <p:stCondLst>
+                                            <p:cond delay="0"/>
+                                          </p:stCondLst>
+                                        </p:cTn>
+                                        <p:tgtEl>
+                                          <p:spTgt spid="3">
+                                            <p:txEl>
+                                              <p:pRg st="3" end="3"/>
+                                            </p:txEl>
+                                          </p:spTgt>
+                                        </p:tgtEl>
+                                        <p:attrNameLst>
+                                          <p:attrName>style.visibility</p:attrName>
+                                        </p:attrNameLst>
+                                      </p:cBhvr>
+                                      <p:to>
+                                        <p:strVal val="visible"/>
+                                      </p:to>
+                                    </p:set>
+                                  </p:childTnLst>
+                                </p:cTn>
+                              </p:par>
+                            </p:childTnLst>
+                          </p:cTn>
+                        </p:par>
+                      </p:childTnLst>
+                    </p:cTn>
+                  </p:par>
+                  <p:par>
+                    <p:cTn id="19" fill="hold">
+                      <p:stCondLst>
+                        <p:cond delay="indefinite"/>
+                      </p:stCondLst>
+                      <p:childTnLst>
+                        <p:par>
+                          <p:cTn id="20" fill="hold">
+                            <p:stCondLst>
+                              <p:cond delay="0"/>
+                            </p:stCondLst>
+                            <p:childTnLst>
+                              <p:par>
+                                <p:cTn id="21" presetID="1" presetClass="entr" presetSubtype="0" fill="hold" grpId="0" nodeType="clickEffect">
+                                  <p:stCondLst>
+                                    <p:cond delay="0"/>
+                                  </p:stCondLst>
+                                  <p:childTnLst>
+                                    <p:set>
+                                      <p:cBhvr>
+                                        <p:cTn id="22" dur="1" fill="hold">
+                                          <p:stCondLst>
+                                            <p:cond delay="0"/>
+                                          </p:stCondLst>
+                                        </p:cTn>
+                                        <p:tgtEl>
+                                          <p:spTgt spid="3">
+                                            <p:txEl>
+                                              <p:pRg st="4" end="4"/>
+                                            </p:txEl>
+                                          </p:spTgt>
+                                        </p:tgtEl>
+                                        <p:attrNameLst>
+                                          <p:attrName>style.visibility</p:attrName>
+                                        </p:attrNameLst>
+                                      </p:cBhvr>
+                                      <p:to>
+                                        <p:strVal val="visible"/>
+                                      </p:to>
+                                    </p:set>
+                                  </p:childTnLst>
+                                </p:cTn>
+                              </p:par>
+                            </p:childTnLst>
+                          </p:cTn>
+                        </p:par>
+                      </p:childTnLst>
+                    </p:cTn>
+                  </p:par>
+                  <p:par>
+                    <p:cTn id="23" fill="hold">
+                      <p:stCondLst>
+                        <p:cond delay="indefinite"/>
+                      </p:stCondLst>
+                      <p:childTnLst>
+                        <p:par>
+                          <p:cTn id="24" fill="hold">
+                            <p:stCondLst>
+                              <p:cond delay="0"/>
+                            </p:stCondLst>
+                            <p:childTnLst>
+                              <p:par>
+                                <p:cTn id="25" presetID="1" presetClass="entr" presetSubtype="0" fill="hold" grpId="0" nodeType="clickEffect">
+                                  <p:stCondLst>
+                                    <p:cond delay="0"/>
+                                  </p:stCondLst>
+                                  <p:childTnLst>
+                                    <p:set>
+                                      <p:cBhvr>
+                                        <p:cTn id="26" dur="1" fill="hold">
+                                          <p:stCondLst>
+                                            <p:cond delay="0"/>
+                                          </p:stCondLst>
+                                        </p:cTn>
+                                        <p:tgtEl>
+                                          <p:spTgt spid="3">
+                                            <p:txEl>
+                                              <p:pRg st="5" end="5"/>
+                                            </p:txEl>
+                                          </p:spTgt>
+                                        </p:tgtEl>
+                                        <p:attrNameLst>
+                                          <p:attrName>style.visibility</p:attrName>
+                                        </p:attrNameLst>
+                                      </p:cBhvr>
+                                      <p:to>
+                                        <p:strVal val="visible"/>
+                                      </p:to>
+                                    </p:set>
+                                  </p:childTnLst>
+                                </p:cTn>
+                              </p:par>
+                            </p:childTnLst>
+                          </p:cTn>
+                        </p:par>
+                      </p:childTnLst>
+                    </p:cTn>
+                  </p:par>
+                </p:childTnLst>
+              </p:cTn>
+              <p:prevCondLst>
+                <p:cond evt="onPrev" delay="0">
+                  <p:tgtEl>
+                    <p:sldTgt/>
+                  </p:tgtEl>
+                </p:cond>
+              </p:prevCondLst>
+              <p:nextCondLst>
+                <p:cond evt="onNext" delay="0">
+                  <p:tgtEl>
+                    <p:sldTgt/>
+                  </p:tgtEl>
+                </p:cond>
+              </p:nextCondLst>
+            </p:seq>
+          </p:childTnLst>
+        </p:cTn>
+      </p:par>
+    </p:tnLst>
+    <p:bldLst>
+      <p:bldP spid="3" grpId="0" build="p"/>
+    </p:bldLst>
+  </p:timing>
+</p:sld>
+</file>
+
+<file path=ppt/slides/slide13.xml><?xml version="1.0" encoding="utf-8"?>
+<p:sld xmlns:a="http://schemas.openxmlformats.org/drawingml/2006/main" xmlns:r="http://schemas.openxmlformats.org/officeDocument/2006/relationships" xmlns:p="http://schemas.openxmlformats.org/presentationml/2006/main">
+  <p:cSld>
+    <p:spTree>
+      <p:nvGrpSpPr>
+        <p:cNvPr id="1" name=""/>
+        <p:cNvGrpSpPr/>
+        <p:nvPr/>
+      </p:nvGrpSpPr>
+      <p:grpSpPr>
+        <a:xfrm>
+          <a:off x="0" y="0"/>
+          <a:ext cx="0" cy="0"/>
+          <a:chOff x="0" y="0"/>
+          <a:chExt cx="0" cy="0"/>
+        </a:xfrm>
+      </p:grpSpPr>
+      <p:sp>
+        <p:nvSpPr>
+          <p:cNvPr id="2" name="Title 1">
+            <a:extLst>
+              <a:ext uri="{FF2B5EF4-FFF2-40B4-BE49-F238E27FC236}">
+                <a16:creationId xmlns:a16="http://schemas.microsoft.com/office/drawing/2014/main" id="{99791269-513E-3C49-D907-EAE400635EA7}"/>
+              </a:ext>
+            </a:extLst>
+          </p:cNvPr>
+          <p:cNvSpPr>
+            <a:spLocks noGrp="1"/>
+          </p:cNvSpPr>
+          <p:nvPr>
+            <p:ph type="title"/>
+          </p:nvPr>
+        </p:nvSpPr>
+        <p:spPr/>
+        <p:txBody>
+          <a:bodyPr/>
+          <a:lstStyle/>
+          <a:p>
+            <a:r>
+              <a:rPr lang="en-US" dirty="0"/>
+              <a:t>How it works…</a:t>
+            </a:r>
+            <a:endParaRPr lang="en-IN" dirty="0"/>
+          </a:p>
+        </p:txBody>
+      </p:sp>
+      <p:sp>
+        <p:nvSpPr>
+          <p:cNvPr id="3" name="Content Placeholder 2">
+            <a:extLst>
+              <a:ext uri="{FF2B5EF4-FFF2-40B4-BE49-F238E27FC236}">
+                <a16:creationId xmlns:a16="http://schemas.microsoft.com/office/drawing/2014/main" id="{4EB4563D-156F-4B38-EB4D-B3D179EEB85A}"/>
+              </a:ext>
+            </a:extLst>
+          </p:cNvPr>
+          <p:cNvSpPr>
+            <a:spLocks noGrp="1"/>
+          </p:cNvSpPr>
+          <p:nvPr>
+            <p:ph idx="1"/>
+          </p:nvPr>
+        </p:nvSpPr>
+        <p:spPr/>
+        <p:txBody>
+          <a:bodyPr>
+            <a:normAutofit fontScale="92500"/>
+          </a:bodyPr>
+          <a:lstStyle/>
+          <a:p>
+            <a:r>
+              <a:rPr lang="en-US" dirty="0"/>
+              <a:t>Register renaming</a:t>
+            </a:r>
+          </a:p>
+          <a:p>
+            <a:pPr lvl="1"/>
+            <a:endParaRPr lang="en-US" dirty="0"/>
+          </a:p>
+          <a:p>
+            <a:pPr lvl="1"/>
+            <a:endParaRPr lang="en-US" dirty="0"/>
+          </a:p>
+          <a:p>
+            <a:pPr lvl="1"/>
+            <a:r>
+              <a:rPr lang="en-US" dirty="0">
+                <a:latin typeface="Cascadia Code" panose="020B0609020000020004" pitchFamily="49" charset="0"/>
+                <a:ea typeface="Cascadia Code" panose="020B0609020000020004" pitchFamily="49" charset="0"/>
+                <a:cs typeface="Cascadia Code" panose="020B0609020000020004" pitchFamily="49" charset="0"/>
+              </a:rPr>
+              <a:t>I1</a:t>
+            </a:r>
+            <a:r>
+              <a:rPr lang="en-US" dirty="0"/>
+              <a:t> and </a:t>
+            </a:r>
+            <a:r>
+              <a:rPr lang="en-US" dirty="0">
+                <a:latin typeface="Cascadia Code" panose="020B0609020000020004" pitchFamily="49" charset="0"/>
+                <a:ea typeface="Cascadia Code" panose="020B0609020000020004" pitchFamily="49" charset="0"/>
+                <a:cs typeface="Cascadia Code" panose="020B0609020000020004" pitchFamily="49" charset="0"/>
+              </a:rPr>
+              <a:t>I3</a:t>
+            </a:r>
+            <a:r>
+              <a:rPr lang="en-US" dirty="0"/>
+              <a:t> are actually independent; yet share a register name, causing potential WAW and WAR hazards</a:t>
+            </a:r>
+          </a:p>
+          <a:p>
+            <a:pPr lvl="1"/>
+            <a:r>
+              <a:rPr lang="en-US" dirty="0"/>
+              <a:t>Translate logical register names (x0 to X31) to physical registers (even hundred are possible to have)</a:t>
+            </a:r>
+          </a:p>
+          <a:p>
+            <a:r>
+              <a:rPr lang="en-US" dirty="0"/>
+              <a:t>Speculative execution</a:t>
+            </a:r>
+          </a:p>
+          <a:p>
+            <a:pPr lvl="1"/>
+            <a:r>
+              <a:rPr lang="en-US" dirty="0"/>
+              <a:t>Not just prefetch branches, but execute branches</a:t>
+            </a:r>
+          </a:p>
+          <a:p>
+            <a:pPr lvl="1"/>
+            <a:r>
+              <a:rPr lang="en-US" dirty="0"/>
+              <a:t>Keep or discard result depending on branch outcome</a:t>
+            </a:r>
+            <a:endParaRPr lang="en-IN" dirty="0"/>
+          </a:p>
+        </p:txBody>
+      </p:sp>
+      <p:sp>
+        <p:nvSpPr>
+          <p:cNvPr id="4" name="Date Placeholder 3">
+            <a:extLst>
+              <a:ext uri="{FF2B5EF4-FFF2-40B4-BE49-F238E27FC236}">
+                <a16:creationId xmlns:a16="http://schemas.microsoft.com/office/drawing/2014/main" id="{8B38DC53-B1F2-9B21-BB78-F3AA7924141A}"/>
+              </a:ext>
+            </a:extLst>
+          </p:cNvPr>
+          <p:cNvSpPr>
+            <a:spLocks noGrp="1"/>
+          </p:cNvSpPr>
+          <p:nvPr>
+            <p:ph type="dt" sz="half" idx="10"/>
+          </p:nvPr>
+        </p:nvSpPr>
+        <p:spPr/>
+        <p:txBody>
+          <a:bodyPr/>
+          <a:lstStyle/>
+          <a:p>
+            <a:pPr>
+              <a:defRPr/>
+            </a:pPr>
+            <a:r>
+              <a:rPr lang="en-US"/>
+              <a:t>21/12/2020</a:t>
+            </a:r>
+          </a:p>
+        </p:txBody>
+      </p:sp>
+      <p:sp>
+        <p:nvSpPr>
+          <p:cNvPr id="5" name="Slide Number Placeholder 4">
+            <a:extLst>
+              <a:ext uri="{FF2B5EF4-FFF2-40B4-BE49-F238E27FC236}">
+                <a16:creationId xmlns:a16="http://schemas.microsoft.com/office/drawing/2014/main" id="{970B22B2-2DCF-8BAB-09F1-2CFA7D581A73}"/>
+              </a:ext>
+            </a:extLst>
+          </p:cNvPr>
+          <p:cNvSpPr>
+            <a:spLocks noGrp="1"/>
+          </p:cNvSpPr>
+          <p:nvPr>
+            <p:ph type="sldNum" sz="quarter" idx="12"/>
+          </p:nvPr>
+        </p:nvSpPr>
+        <p:spPr/>
+        <p:txBody>
+          <a:bodyPr/>
+          <a:lstStyle/>
+          <a:p>
+            <a:pPr>
+              <a:defRPr/>
+            </a:pPr>
+            <a:fld id="{CA887A73-1AE0-46F8-856A-18EA1CF30A1B}" type="slidenum">
+              <a:rPr lang="en-US" altLang="en-US" smtClean="0"/>
+              <a:pPr>
+                <a:defRPr/>
+              </a:pPr>
+              <a:t>13</a:t>
+            </a:fld>
+            <a:endParaRPr lang="en-US" altLang="en-US"/>
+          </a:p>
+        </p:txBody>
+      </p:sp>
+      <p:sp>
+        <p:nvSpPr>
+          <p:cNvPr id="7" name="TextBox 6">
+            <a:extLst>
+              <a:ext uri="{FF2B5EF4-FFF2-40B4-BE49-F238E27FC236}">
+                <a16:creationId xmlns:a16="http://schemas.microsoft.com/office/drawing/2014/main" id="{62CBB3F9-247A-1ED6-9EF4-5D9C46507E7F}"/>
+              </a:ext>
+            </a:extLst>
+          </p:cNvPr>
+          <p:cNvSpPr txBox="1"/>
+          <p:nvPr/>
+        </p:nvSpPr>
+        <p:spPr>
+          <a:xfrm>
+            <a:off x="2277836" y="2048470"/>
+            <a:ext cx="4588328" cy="923330"/>
+          </a:xfrm>
+          <a:prstGeom prst="rect">
+            <a:avLst/>
+          </a:prstGeom>
+          <a:noFill/>
+        </p:spPr>
+        <p:txBody>
+          <a:bodyPr wrap="square">
+            <a:spAutoFit/>
+          </a:bodyPr>
+          <a:lstStyle/>
+          <a:p>
+            <a:pPr algn="ctr"/>
+            <a:r>
+              <a:rPr lang="it-IT" b="1" dirty="0">
+                <a:solidFill>
+                  <a:srgbClr val="FFC000"/>
+                </a:solidFill>
+                <a:latin typeface="Cascadia Code" panose="020B0609020000020004" pitchFamily="49" charset="0"/>
+                <a:ea typeface="Cascadia Code" panose="020B0609020000020004" pitchFamily="49" charset="0"/>
+                <a:cs typeface="Cascadia Code" panose="020B0609020000020004" pitchFamily="49" charset="0"/>
+              </a:rPr>
+              <a:t>I1: add x1, x2, x3</a:t>
+            </a:r>
+            <a:br>
+              <a:rPr lang="it-IT" b="1" dirty="0">
+                <a:solidFill>
+                  <a:srgbClr val="FFC000"/>
+                </a:solidFill>
+                <a:latin typeface="Cascadia Code" panose="020B0609020000020004" pitchFamily="49" charset="0"/>
+                <a:ea typeface="Cascadia Code" panose="020B0609020000020004" pitchFamily="49" charset="0"/>
+                <a:cs typeface="Cascadia Code" panose="020B0609020000020004" pitchFamily="49" charset="0"/>
+              </a:rPr>
+            </a:br>
+            <a:r>
+              <a:rPr lang="it-IT" b="1" dirty="0">
+                <a:solidFill>
+                  <a:srgbClr val="FFC000"/>
+                </a:solidFill>
+                <a:latin typeface="Cascadia Code" panose="020B0609020000020004" pitchFamily="49" charset="0"/>
+                <a:ea typeface="Cascadia Code" panose="020B0609020000020004" pitchFamily="49" charset="0"/>
+                <a:cs typeface="Cascadia Code" panose="020B0609020000020004" pitchFamily="49" charset="0"/>
+              </a:rPr>
+              <a:t>I2: add x4, x5, x6</a:t>
+            </a:r>
+            <a:br>
+              <a:rPr lang="it-IT" b="1" dirty="0">
+                <a:solidFill>
+                  <a:srgbClr val="FFC000"/>
+                </a:solidFill>
+                <a:latin typeface="Cascadia Code" panose="020B0609020000020004" pitchFamily="49" charset="0"/>
+                <a:ea typeface="Cascadia Code" panose="020B0609020000020004" pitchFamily="49" charset="0"/>
+                <a:cs typeface="Cascadia Code" panose="020B0609020000020004" pitchFamily="49" charset="0"/>
+              </a:rPr>
+            </a:br>
+            <a:r>
+              <a:rPr lang="it-IT" b="1" dirty="0">
+                <a:solidFill>
+                  <a:srgbClr val="FFC000"/>
+                </a:solidFill>
+                <a:latin typeface="Cascadia Code" panose="020B0609020000020004" pitchFamily="49" charset="0"/>
+                <a:ea typeface="Cascadia Code" panose="020B0609020000020004" pitchFamily="49" charset="0"/>
+                <a:cs typeface="Cascadia Code" panose="020B0609020000020004" pitchFamily="49" charset="0"/>
+              </a:rPr>
+              <a:t>I3: add x1, x7, x8</a:t>
+            </a:r>
+            <a:endParaRPr lang="en-IN" b="1" dirty="0">
+              <a:solidFill>
+                <a:srgbClr val="FFC000"/>
+              </a:solidFill>
+              <a:latin typeface="Cascadia Code" panose="020B0609020000020004" pitchFamily="49" charset="0"/>
+              <a:ea typeface="Cascadia Code" panose="020B0609020000020004" pitchFamily="49" charset="0"/>
+              <a:cs typeface="Cascadia Code" panose="020B0609020000020004" pitchFamily="49" charset="0"/>
+            </a:endParaRPr>
+          </a:p>
+        </p:txBody>
+      </p:sp>
+    </p:spTree>
+    <p:extLst>
+      <p:ext uri="{BB962C8B-B14F-4D97-AF65-F5344CB8AC3E}">
+        <p14:creationId xmlns:p14="http://schemas.microsoft.com/office/powerpoint/2010/main" val="2165761925"/>
+      </p:ext>
+    </p:extLst>
+  </p:cSld>
+  <p:clrMapOvr>
+    <a:masterClrMapping/>
+  </p:clrMapOvr>
+  <p:timing>
+    <p:tnLst>
+      <p:par>
+        <p:cTn id="1" dur="indefinite" restart="never" nodeType="tmRoot">
+          <p:childTnLst>
+            <p:seq concurrent="1" nextAc="seek">
+              <p:cTn id="2" dur="indefinite" nodeType="mainSeq">
+                <p:childTnLst>
+                  <p:par>
+                    <p:cTn id="3" fill="hold">
+                      <p:stCondLst>
+                        <p:cond delay="indefinite"/>
+                      </p:stCondLst>
+                      <p:childTnLst>
+                        <p:par>
+                          <p:cTn id="4" fill="hold">
+                            <p:stCondLst>
+                              <p:cond delay="0"/>
+                            </p:stCondLst>
+                            <p:childTnLst>
+                              <p:par>
+                                <p:cTn id="5" presetID="1" presetClass="entr" presetSubtype="0" fill="hold" grpId="0" nodeType="clickEffect">
+                                  <p:stCondLst>
+                                    <p:cond delay="0"/>
+                                  </p:stCondLst>
+                                  <p:childTnLst>
+                                    <p:set>
+                                      <p:cBhvr>
+                                        <p:cTn id="6" dur="1" fill="hold">
+                                          <p:stCondLst>
+                                            <p:cond delay="0"/>
+                                          </p:stCondLst>
+                                        </p:cTn>
+                                        <p:tgtEl>
+                                          <p:spTgt spid="3">
+                                            <p:txEl>
+                                              <p:pRg st="0" end="0"/>
+                                            </p:txEl>
+                                          </p:spTgt>
+                                        </p:tgtEl>
+                                        <p:attrNameLst>
+                                          <p:attrName>style.visibility</p:attrName>
+                                        </p:attrNameLst>
+                                      </p:cBhvr>
+                                      <p:to>
+                                        <p:strVal val="visible"/>
+                                      </p:to>
+                                    </p:set>
+                                  </p:childTnLst>
+                                </p:cTn>
+                              </p:par>
+                            </p:childTnLst>
+                          </p:cTn>
+                        </p:par>
+                      </p:childTnLst>
+                    </p:cTn>
+                  </p:par>
+                  <p:par>
+                    <p:cTn id="7" fill="hold">
+                      <p:stCondLst>
+                        <p:cond delay="indefinite"/>
+                      </p:stCondLst>
+                      <p:childTnLst>
+                        <p:par>
+                          <p:cTn id="8" fill="hold">
+                            <p:stCondLst>
+                              <p:cond delay="0"/>
+                            </p:stCondLst>
+                            <p:childTnLst>
+                              <p:par>
+                                <p:cTn id="9" presetID="1" presetClass="entr" presetSubtype="0" fill="hold" grpId="0" nodeType="clickEffect">
+                                  <p:stCondLst>
+                                    <p:cond delay="0"/>
+                                  </p:stCondLst>
+                                  <p:childTnLst>
+                                    <p:set>
+                                      <p:cBhvr>
+                                        <p:cTn id="10" dur="1" fill="hold">
+                                          <p:stCondLst>
+                                            <p:cond delay="0"/>
+                                          </p:stCondLst>
+                                        </p:cTn>
+                                        <p:tgtEl>
+                                          <p:spTgt spid="7"/>
+                                        </p:tgtEl>
+                                        <p:attrNameLst>
+                                          <p:attrName>style.visibility</p:attrName>
+                                        </p:attrNameLst>
+                                      </p:cBhvr>
+                                      <p:to>
+                                        <p:strVal val="visible"/>
+                                      </p:to>
+                                    </p:set>
+                                  </p:childTnLst>
+                                </p:cTn>
+                              </p:par>
+                            </p:childTnLst>
+                          </p:cTn>
+                        </p:par>
+                      </p:childTnLst>
+                    </p:cTn>
+                  </p:par>
+                  <p:par>
+                    <p:cTn id="11" fill="hold">
+                      <p:stCondLst>
+                        <p:cond delay="indefinite"/>
+                      </p:stCondLst>
+                      <p:childTnLst>
+                        <p:par>
+                          <p:cTn id="12" fill="hold">
+                            <p:stCondLst>
+                              <p:cond delay="0"/>
+                            </p:stCondLst>
+                            <p:childTnLst>
+                              <p:par>
+                                <p:cTn id="13" presetID="1" presetClass="entr" presetSubtype="0" fill="hold" grpId="0" nodeType="clickEffect">
+                                  <p:stCondLst>
+                                    <p:cond delay="0"/>
+                                  </p:stCondLst>
+                                  <p:childTnLst>
+                                    <p:set>
+                                      <p:cBhvr>
+                                        <p:cTn id="14" dur="1" fill="hold">
+                                          <p:stCondLst>
+                                            <p:cond delay="0"/>
+                                          </p:stCondLst>
+                                        </p:cTn>
+                                        <p:tgtEl>
+                                          <p:spTgt spid="3">
+                                            <p:txEl>
+                                              <p:pRg st="3" end="3"/>
+                                            </p:txEl>
+                                          </p:spTgt>
+                                        </p:tgtEl>
+                                        <p:attrNameLst>
+                                          <p:attrName>style.visibility</p:attrName>
+                                        </p:attrNameLst>
+                                      </p:cBhvr>
+                                      <p:to>
+                                        <p:strVal val="visible"/>
+                                      </p:to>
+                                    </p:set>
+                                  </p:childTnLst>
+                                </p:cTn>
+                              </p:par>
+                            </p:childTnLst>
+                          </p:cTn>
+                        </p:par>
+                      </p:childTnLst>
+                    </p:cTn>
+                  </p:par>
+                  <p:par>
+                    <p:cTn id="15" fill="hold">
+                      <p:stCondLst>
+                        <p:cond delay="indefinite"/>
+                      </p:stCondLst>
+                      <p:childTnLst>
+                        <p:par>
+                          <p:cTn id="16" fill="hold">
+                            <p:stCondLst>
+                              <p:cond delay="0"/>
+                            </p:stCondLst>
+                            <p:childTnLst>
+                              <p:par>
+                                <p:cTn id="17" presetID="1" presetClass="entr" presetSubtype="0" fill="hold" grpId="0" nodeType="clickEffect">
+                                  <p:stCondLst>
+                                    <p:cond delay="0"/>
+                                  </p:stCondLst>
+                                  <p:childTnLst>
+                                    <p:set>
+                                      <p:cBhvr>
+                                        <p:cTn id="18" dur="1" fill="hold">
+                                          <p:stCondLst>
+                                            <p:cond delay="0"/>
+                                          </p:stCondLst>
+                                        </p:cTn>
+                                        <p:tgtEl>
+                                          <p:spTgt spid="3">
+                                            <p:txEl>
+                                              <p:pRg st="4" end="4"/>
+                                            </p:txEl>
+                                          </p:spTgt>
+                                        </p:tgtEl>
+                                        <p:attrNameLst>
+                                          <p:attrName>style.visibility</p:attrName>
+                                        </p:attrNameLst>
+                                      </p:cBhvr>
+                                      <p:to>
+                                        <p:strVal val="visible"/>
+                                      </p:to>
+                                    </p:set>
+                                  </p:childTnLst>
+                                </p:cTn>
+                              </p:par>
+                            </p:childTnLst>
+                          </p:cTn>
+                        </p:par>
+                      </p:childTnLst>
+                    </p:cTn>
+                  </p:par>
+                  <p:par>
+                    <p:cTn id="19" fill="hold">
+                      <p:stCondLst>
+                        <p:cond delay="indefinite"/>
+                      </p:stCondLst>
+                      <p:childTnLst>
+                        <p:par>
+                          <p:cTn id="20" fill="hold">
+                            <p:stCondLst>
+                              <p:cond delay="0"/>
+                            </p:stCondLst>
+                            <p:childTnLst>
+                              <p:par>
+                                <p:cTn id="21" presetID="1" presetClass="entr" presetSubtype="0" fill="hold" grpId="0" nodeType="clickEffect">
+                                  <p:stCondLst>
+                                    <p:cond delay="0"/>
+                                  </p:stCondLst>
+                                  <p:childTnLst>
+                                    <p:set>
+                                      <p:cBhvr>
+                                        <p:cTn id="22" dur="1" fill="hold">
+                                          <p:stCondLst>
+                                            <p:cond delay="0"/>
+                                          </p:stCondLst>
+                                        </p:cTn>
+                                        <p:tgtEl>
+                                          <p:spTgt spid="3">
+                                            <p:txEl>
+                                              <p:pRg st="5" end="5"/>
+                                            </p:txEl>
+                                          </p:spTgt>
+                                        </p:tgtEl>
+                                        <p:attrNameLst>
+                                          <p:attrName>style.visibility</p:attrName>
+                                        </p:attrNameLst>
+                                      </p:cBhvr>
+                                      <p:to>
+                                        <p:strVal val="visible"/>
+                                      </p:to>
+                                    </p:set>
+                                  </p:childTnLst>
+                                </p:cTn>
+                              </p:par>
+                            </p:childTnLst>
+                          </p:cTn>
+                        </p:par>
+                      </p:childTnLst>
+                    </p:cTn>
+                  </p:par>
+                  <p:par>
+                    <p:cTn id="23" fill="hold">
+                      <p:stCondLst>
+                        <p:cond delay="indefinite"/>
+                      </p:stCondLst>
+                      <p:childTnLst>
+                        <p:par>
+                          <p:cTn id="24" fill="hold">
+                            <p:stCondLst>
+                              <p:cond delay="0"/>
+                            </p:stCondLst>
+                            <p:childTnLst>
+                              <p:par>
+                                <p:cTn id="25" presetID="1" presetClass="entr" presetSubtype="0" fill="hold" grpId="0" nodeType="clickEffect">
+                                  <p:stCondLst>
+                                    <p:cond delay="0"/>
+                                  </p:stCondLst>
+                                  <p:childTnLst>
+                                    <p:set>
+                                      <p:cBhvr>
+                                        <p:cTn id="26" dur="1" fill="hold">
+                                          <p:stCondLst>
+                                            <p:cond delay="0"/>
+                                          </p:stCondLst>
+                                        </p:cTn>
+                                        <p:tgtEl>
+                                          <p:spTgt spid="3">
+                                            <p:txEl>
+                                              <p:pRg st="6" end="6"/>
+                                            </p:txEl>
+                                          </p:spTgt>
+                                        </p:tgtEl>
+                                        <p:attrNameLst>
+                                          <p:attrName>style.visibility</p:attrName>
+                                        </p:attrNameLst>
+                                      </p:cBhvr>
+                                      <p:to>
+                                        <p:strVal val="visible"/>
+                                      </p:to>
+                                    </p:set>
+                                  </p:childTnLst>
+                                </p:cTn>
+                              </p:par>
+                            </p:childTnLst>
+                          </p:cTn>
+                        </p:par>
+                      </p:childTnLst>
+                    </p:cTn>
+                  </p:par>
+                  <p:par>
+                    <p:cTn id="27" fill="hold">
+                      <p:stCondLst>
+                        <p:cond delay="indefinite"/>
+                      </p:stCondLst>
+                      <p:childTnLst>
+                        <p:par>
+                          <p:cTn id="28" fill="hold">
+                            <p:stCondLst>
+                              <p:cond delay="0"/>
+                            </p:stCondLst>
+                            <p:childTnLst>
+                              <p:par>
+                                <p:cTn id="29" presetID="1" presetClass="entr" presetSubtype="0" fill="hold" grpId="0" nodeType="clickEffect">
+                                  <p:stCondLst>
+                                    <p:cond delay="0"/>
+                                  </p:stCondLst>
+                                  <p:childTnLst>
+                                    <p:set>
+                                      <p:cBhvr>
+                                        <p:cTn id="30" dur="1" fill="hold">
+                                          <p:stCondLst>
+                                            <p:cond delay="0"/>
+                                          </p:stCondLst>
+                                        </p:cTn>
+                                        <p:tgtEl>
+                                          <p:spTgt spid="3">
+                                            <p:txEl>
+                                              <p:pRg st="7" end="7"/>
+                                            </p:txEl>
+                                          </p:spTgt>
+                                        </p:tgtEl>
+                                        <p:attrNameLst>
+                                          <p:attrName>style.visibility</p:attrName>
+                                        </p:attrNameLst>
+                                      </p:cBhvr>
+                                      <p:to>
+                                        <p:strVal val="visible"/>
+                                      </p:to>
+                                    </p:set>
+                                  </p:childTnLst>
+                                </p:cTn>
+                              </p:par>
+                            </p:childTnLst>
+                          </p:cTn>
+                        </p:par>
+                      </p:childTnLst>
+                    </p:cTn>
+                  </p:par>
+                </p:childTnLst>
+              </p:cTn>
+              <p:prevCondLst>
+                <p:cond evt="onPrev" delay="0">
+                  <p:tgtEl>
+                    <p:sldTgt/>
+                  </p:tgtEl>
+                </p:cond>
+              </p:prevCondLst>
+              <p:nextCondLst>
+                <p:cond evt="onNext" delay="0">
+                  <p:tgtEl>
+                    <p:sldTgt/>
+                  </p:tgtEl>
+                </p:cond>
+              </p:nextCondLst>
+            </p:seq>
+          </p:childTnLst>
+        </p:cTn>
+      </p:par>
+    </p:tnLst>
+    <p:bldLst>
+      <p:bldP spid="3" grpId="0" uiExpand="1" build="p"/>
+      <p:bldP spid="7" grpId="0"/>
+    </p:bldLst>
+  </p:timing>
+</p:sld>
+</file>
+
+<file path=ppt/slides/slide14.xml><?xml version="1.0" encoding="utf-8"?>
+<p:sld xmlns:a="http://schemas.openxmlformats.org/drawingml/2006/main" xmlns:r="http://schemas.openxmlformats.org/officeDocument/2006/relationships" xmlns:p="http://schemas.openxmlformats.org/presentationml/2006/main">
+  <p:cSld>
+    <p:spTree>
+      <p:nvGrpSpPr>
+        <p:cNvPr id="1" name=""/>
+        <p:cNvGrpSpPr/>
+        <p:nvPr/>
+      </p:nvGrpSpPr>
+      <p:grpSpPr>
+        <a:xfrm>
+          <a:off x="0" y="0"/>
+          <a:ext cx="0" cy="0"/>
+          <a:chOff x="0" y="0"/>
+          <a:chExt cx="0" cy="0"/>
+        </a:xfrm>
+      </p:grpSpPr>
+      <p:sp>
+        <p:nvSpPr>
+          <p:cNvPr id="2" name="Title 1">
+            <a:extLst>
+              <a:ext uri="{FF2B5EF4-FFF2-40B4-BE49-F238E27FC236}">
+                <a16:creationId xmlns:a16="http://schemas.microsoft.com/office/drawing/2014/main" id="{99CED3AE-BDEB-5256-7052-BC4D2AC35CC3}"/>
+              </a:ext>
+            </a:extLst>
+          </p:cNvPr>
+          <p:cNvSpPr>
+            <a:spLocks noGrp="1"/>
+          </p:cNvSpPr>
+          <p:nvPr>
+            <p:ph type="title"/>
+          </p:nvPr>
+        </p:nvSpPr>
+        <p:spPr/>
+        <p:txBody>
+          <a:bodyPr/>
+          <a:lstStyle/>
+          <a:p>
+            <a:r>
+              <a:rPr lang="en-US" dirty="0"/>
+              <a:t>How it looks like</a:t>
+            </a:r>
+            <a:endParaRPr lang="en-IN" dirty="0"/>
+          </a:p>
+        </p:txBody>
+      </p:sp>
+      <p:sp>
+        <p:nvSpPr>
+          <p:cNvPr id="4" name="Date Placeholder 3">
+            <a:extLst>
+              <a:ext uri="{FF2B5EF4-FFF2-40B4-BE49-F238E27FC236}">
+                <a16:creationId xmlns:a16="http://schemas.microsoft.com/office/drawing/2014/main" id="{33F98116-84F4-6FDE-08B5-68CD21DA1F55}"/>
+              </a:ext>
+            </a:extLst>
+          </p:cNvPr>
+          <p:cNvSpPr>
+            <a:spLocks noGrp="1"/>
+          </p:cNvSpPr>
+          <p:nvPr>
+            <p:ph type="dt" sz="half" idx="10"/>
+          </p:nvPr>
+        </p:nvSpPr>
+        <p:spPr/>
+        <p:txBody>
+          <a:bodyPr/>
+          <a:lstStyle/>
+          <a:p>
+            <a:pPr>
+              <a:defRPr/>
+            </a:pPr>
+            <a:r>
+              <a:rPr lang="en-US"/>
+              <a:t>21/12/2020</a:t>
+            </a:r>
+          </a:p>
+        </p:txBody>
+      </p:sp>
+      <p:sp>
+        <p:nvSpPr>
+          <p:cNvPr id="5" name="Slide Number Placeholder 4">
+            <a:extLst>
+              <a:ext uri="{FF2B5EF4-FFF2-40B4-BE49-F238E27FC236}">
+                <a16:creationId xmlns:a16="http://schemas.microsoft.com/office/drawing/2014/main" id="{FDBA808E-BBAB-F159-5885-A7886165F0EC}"/>
+              </a:ext>
+            </a:extLst>
+          </p:cNvPr>
+          <p:cNvSpPr>
+            <a:spLocks noGrp="1"/>
+          </p:cNvSpPr>
+          <p:nvPr>
+            <p:ph type="sldNum" sz="quarter" idx="12"/>
+          </p:nvPr>
+        </p:nvSpPr>
+        <p:spPr/>
+        <p:txBody>
+          <a:bodyPr/>
+          <a:lstStyle/>
+          <a:p>
+            <a:pPr>
+              <a:defRPr/>
+            </a:pPr>
+            <a:fld id="{CA887A73-1AE0-46F8-856A-18EA1CF30A1B}" type="slidenum">
+              <a:rPr lang="en-US" altLang="en-US" smtClean="0"/>
+              <a:pPr>
+                <a:defRPr/>
+              </a:pPr>
+              <a:t>14</a:t>
+            </a:fld>
+            <a:endParaRPr lang="en-US" altLang="en-US"/>
+          </a:p>
+        </p:txBody>
+      </p:sp>
+      <p:pic>
+        <p:nvPicPr>
+          <p:cNvPr id="8" name="Online Media 7" title="Out-of-Order Execution (Tomasulo's Algorithm)">
+            <a:hlinkClick r:id="" action="ppaction://media"/>
+            <a:extLst>
+              <a:ext uri="{FF2B5EF4-FFF2-40B4-BE49-F238E27FC236}">
+                <a16:creationId xmlns:a16="http://schemas.microsoft.com/office/drawing/2014/main" id="{428F2D92-3D89-5035-C9A1-A6AD52FB24A9}"/>
+              </a:ext>
+            </a:extLst>
+          </p:cNvPr>
+          <p:cNvPicPr>
+            <a:picLocks noRot="1" noChangeAspect="1"/>
+          </p:cNvPicPr>
+          <p:nvPr>
+            <a:videoFile r:link="rId1"/>
+          </p:nvPr>
+        </p:nvPicPr>
+        <p:blipFill>
+          <a:blip r:embed="rId3"/>
+          <a:stretch>
+            <a:fillRect/>
+          </a:stretch>
+        </p:blipFill>
+        <p:spPr>
+          <a:xfrm>
+            <a:off x="762000" y="1771649"/>
+            <a:ext cx="7620000" cy="4305300"/>
+          </a:xfrm>
+          <a:prstGeom prst="rect">
+            <a:avLst/>
+          </a:prstGeom>
+        </p:spPr>
+      </p:pic>
+    </p:spTree>
+    <p:extLst>
+      <p:ext uri="{BB962C8B-B14F-4D97-AF65-F5344CB8AC3E}">
+        <p14:creationId xmlns:p14="http://schemas.microsoft.com/office/powerpoint/2010/main" val="3629426581"/>
+      </p:ext>
+    </p:extLst>
+  </p:cSld>
+  <p:clrMapOvr>
+    <a:masterClrMapping/>
+  </p:clrMapOvr>
+  <p:timing>
+    <p:tnLst>
+      <p:par>
+        <p:cTn id="1" dur="indefinite" restart="never" nodeType="tmRoot">
+          <p:childTnLst>
+            <p:seq concurrent="1" nextAc="seek">
+              <p:cTn id="2" dur="indefinite" nodeType="mainSeq">
+                <p:childTnLst>
+                  <p:par>
+                    <p:cTn id="3" fill="hold">
+                      <p:stCondLst>
+                        <p:cond delay="indefinite"/>
+                      </p:stCondLst>
+                      <p:childTnLst>
+                        <p:par>
+                          <p:cTn id="4" fill="hold">
+                            <p:stCondLst>
+                              <p:cond delay="0"/>
+                            </p:stCondLst>
+                            <p:childTnLst>
+                              <p:par>
+                                <p:cTn id="5" presetID="1" presetClass="mediacall" presetSubtype="0" fill="hold" nodeType="clickEffect">
+                                  <p:stCondLst>
+                                    <p:cond delay="0"/>
+                                  </p:stCondLst>
+                                  <p:childTnLst>
+                                    <p:cmd type="call" cmd="playFrom(0.0)">
+                                      <p:cBhvr>
+                                        <p:cTn id="6" dur="1" fill="hold"/>
+                                        <p:tgtEl>
+                                          <p:spTgt spid="8"/>
+                                        </p:tgtEl>
+                                      </p:cBhvr>
+                                    </p:cmd>
+                                  </p:childTnLst>
+                                </p:cTn>
+                              </p:par>
+                            </p:childTnLst>
+                          </p:cTn>
+                        </p:par>
+                      </p:childTnLst>
+                    </p:cTn>
+                  </p:par>
+                </p:childTnLst>
+              </p:cTn>
+              <p:prevCondLst>
+                <p:cond evt="onPrev" delay="0">
+                  <p:tgtEl>
+                    <p:sldTgt/>
+                  </p:tgtEl>
+                </p:cond>
+              </p:prevCondLst>
+              <p:nextCondLst>
+                <p:cond evt="onNext" delay="0">
+                  <p:tgtEl>
+                    <p:sldTgt/>
+                  </p:tgtEl>
+                </p:cond>
+              </p:nextCondLst>
+            </p:seq>
+            <p:video>
+              <p:cMediaNode vol="80000">
+                <p:cTn id="7" fill="hold" display="0">
+                  <p:stCondLst>
+                    <p:cond delay="indefinite"/>
+                  </p:stCondLst>
+                </p:cTn>
+                <p:tgtEl>
+                  <p:spTgt spid="8"/>
+                </p:tgtEl>
+              </p:cMediaNode>
+            </p:video>
+            <p:seq concurrent="1" nextAc="seek">
+              <p:cTn id="8" restart="whenNotActive" fill="hold" evtFilter="cancelBubble" nodeType="interactiveSeq">
+                <p:stCondLst>
+                  <p:cond evt="onClick" delay="0">
+                    <p:tgtEl>
+                      <p:spTgt spid="8"/>
+                    </p:tgtEl>
+                  </p:cond>
+                </p:stCondLst>
+                <p:endSync evt="end" delay="0">
+                  <p:rtn val="all"/>
+                </p:endSync>
+                <p:childTnLst>
+                  <p:par>
+                    <p:cTn id="9" fill="hold">
+                      <p:stCondLst>
+                        <p:cond delay="0"/>
+                      </p:stCondLst>
+                      <p:childTnLst>
+                        <p:par>
+                          <p:cTn id="10" fill="hold">
+                            <p:stCondLst>
+                              <p:cond delay="0"/>
+                            </p:stCondLst>
+                            <p:childTnLst>
+                              <p:par>
+                                <p:cTn id="11" presetID="2" presetClass="mediacall" presetSubtype="0" fill="hold" nodeType="clickEffect">
+                                  <p:stCondLst>
+                                    <p:cond delay="0"/>
+                                  </p:stCondLst>
+                                  <p:childTnLst>
+                                    <p:cmd type="call" cmd="togglePause">
+                                      <p:cBhvr>
+                                        <p:cTn id="12" dur="1" fill="hold"/>
+                                        <p:tgtEl>
+                                          <p:spTgt spid="8"/>
+                                        </p:tgtEl>
+                                      </p:cBhvr>
+                                    </p:cmd>
+                                  </p:childTnLst>
+                                </p:cTn>
+                              </p:par>
+                            </p:childTnLst>
+                          </p:cTn>
+                        </p:par>
+                      </p:childTnLst>
+                    </p:cTn>
+                  </p:par>
+                </p:childTnLst>
+              </p:cTn>
+              <p:nextCondLst>
+                <p:cond evt="onClick" delay="0">
+                  <p:tgtEl>
+                    <p:spTgt spid="8"/>
+                  </p:tgtEl>
+                </p:cond>
+              </p:nextCondLst>
+            </p:seq>
+          </p:childTnLst>
+        </p:cTn>
+      </p:par>
+    </p:tnLst>
+  </p:timing>
+</p:sld>
+</file>
+
+<file path=ppt/slides/slide2.xml><?xml version="1.0" encoding="utf-8"?>
 <p:sld xmlns:a="http://schemas.openxmlformats.org/drawingml/2006/main" xmlns:r="http://schemas.openxmlformats.org/officeDocument/2006/relationships" xmlns:p="http://schemas.openxmlformats.org/presentationml/2006/main">
   <p:cSld>
     <p:spTree>
@@ -6225,7 +8881,7 @@
               <a:pPr>
                 <a:defRPr/>
               </a:pPr>
-              <a:t>3</a:t>
+              <a:t>2</a:t>
             </a:fld>
             <a:endParaRPr lang="en-US" altLang="en-US"/>
           </a:p>
@@ -6522,7 +9178,7 @@
 </p:sld>
 </file>
 
-<file path=ppt/slides/slide4.xml><?xml version="1.0" encoding="utf-8"?>
+<file path=ppt/slides/slide3.xml><?xml version="1.0" encoding="utf-8"?>
 <p:sld xmlns:a="http://schemas.openxmlformats.org/drawingml/2006/main" xmlns:r="http://schemas.openxmlformats.org/officeDocument/2006/relationships" xmlns:p="http://schemas.openxmlformats.org/presentationml/2006/main">
   <p:cSld>
     <p:spTree>
@@ -6728,7 +9384,7 @@
               <a:pPr>
                 <a:defRPr/>
               </a:pPr>
-              <a:t>4</a:t>
+              <a:t>3</a:t>
             </a:fld>
             <a:endParaRPr lang="en-US" altLang="en-US"/>
           </a:p>
@@ -7172,7 +9828,7 @@
 </p:sld>
 </file>
 
-<file path=ppt/slides/slide5.xml><?xml version="1.0" encoding="utf-8"?>
+<file path=ppt/slides/slide4.xml><?xml version="1.0" encoding="utf-8"?>
 <p:sld xmlns:a="http://schemas.openxmlformats.org/drawingml/2006/main" xmlns:r="http://schemas.openxmlformats.org/officeDocument/2006/relationships" xmlns:p="http://schemas.openxmlformats.org/presentationml/2006/main">
   <p:cSld>
     <p:spTree>
@@ -7436,7 +10092,7 @@
               <a:pPr>
                 <a:defRPr/>
               </a:pPr>
-              <a:t>5</a:t>
+              <a:t>4</a:t>
             </a:fld>
             <a:endParaRPr lang="en-US" altLang="en-US"/>
           </a:p>
@@ -8272,7 +10928,7 @@
 </p:sld>
 </file>
 
-<file path=ppt/slides/slide6.xml><?xml version="1.0" encoding="utf-8"?>
+<file path=ppt/slides/slide5.xml><?xml version="1.0" encoding="utf-8"?>
 <p:sld xmlns:a="http://schemas.openxmlformats.org/drawingml/2006/main" xmlns:r="http://schemas.openxmlformats.org/officeDocument/2006/relationships" xmlns:p="http://schemas.openxmlformats.org/presentationml/2006/main">
   <p:cSld>
     <p:spTree>
@@ -8439,7 +11095,7 @@
               <a:pPr>
                 <a:defRPr/>
               </a:pPr>
-              <a:t>6</a:t>
+              <a:t>5</a:t>
             </a:fld>
             <a:endParaRPr lang="en-US" altLang="en-US"/>
           </a:p>
@@ -11798,7 +14454,7 @@
 </p:sld>
 </file>
 
-<file path=ppt/slides/slide7.xml><?xml version="1.0" encoding="utf-8"?>
+<file path=ppt/slides/slide6.xml><?xml version="1.0" encoding="utf-8"?>
 <p:sld xmlns:a="http://schemas.openxmlformats.org/drawingml/2006/main" xmlns:r="http://schemas.openxmlformats.org/officeDocument/2006/relationships" xmlns:p="http://schemas.openxmlformats.org/presentationml/2006/main">
   <p:cSld>
     <p:spTree>
@@ -12439,7 +15095,7 @@
               <a:pPr>
                 <a:defRPr/>
               </a:pPr>
-              <a:t>7</a:t>
+              <a:t>6</a:t>
             </a:fld>
             <a:endParaRPr lang="en-US" altLang="en-US"/>
           </a:p>
@@ -13097,7 +15753,7 @@
 </p:sld>
 </file>
 
-<file path=ppt/slides/slide8.xml><?xml version="1.0" encoding="utf-8"?>
+<file path=ppt/slides/slide7.xml><?xml version="1.0" encoding="utf-8"?>
 <p:sld xmlns:a="http://schemas.openxmlformats.org/drawingml/2006/main" xmlns:r="http://schemas.openxmlformats.org/officeDocument/2006/relationships" xmlns:p="http://schemas.openxmlformats.org/presentationml/2006/main">
   <p:cSld>
     <p:spTree>
@@ -13302,7 +15958,7 @@
               <a:pPr>
                 <a:defRPr/>
               </a:pPr>
-              <a:t>8</a:t>
+              <a:t>7</a:t>
             </a:fld>
             <a:endParaRPr lang="en-US" altLang="en-US"/>
           </a:p>
@@ -13893,6 +16549,184 @@
 </p:sld>
 </file>
 
+<file path=ppt/slides/slide8.xml><?xml version="1.0" encoding="utf-8"?>
+<p:sld xmlns:a="http://schemas.openxmlformats.org/drawingml/2006/main" xmlns:r="http://schemas.openxmlformats.org/officeDocument/2006/relationships" xmlns:p="http://schemas.openxmlformats.org/presentationml/2006/main">
+  <p:cSld>
+    <p:spTree>
+      <p:nvGrpSpPr>
+        <p:cNvPr id="1" name=""/>
+        <p:cNvGrpSpPr/>
+        <p:nvPr/>
+      </p:nvGrpSpPr>
+      <p:grpSpPr>
+        <a:xfrm>
+          <a:off x="0" y="0"/>
+          <a:ext cx="0" cy="0"/>
+          <a:chOff x="0" y="0"/>
+          <a:chExt cx="0" cy="0"/>
+        </a:xfrm>
+      </p:grpSpPr>
+      <p:sp>
+        <p:nvSpPr>
+          <p:cNvPr id="2" name="Title 1">
+            <a:extLst>
+              <a:ext uri="{FF2B5EF4-FFF2-40B4-BE49-F238E27FC236}">
+                <a16:creationId xmlns:a16="http://schemas.microsoft.com/office/drawing/2014/main" id="{EA1D3003-10BB-CA85-87E4-4F3F1A102D12}"/>
+              </a:ext>
+            </a:extLst>
+          </p:cNvPr>
+          <p:cNvSpPr>
+            <a:spLocks noGrp="1"/>
+          </p:cNvSpPr>
+          <p:nvPr>
+            <p:ph type="title"/>
+          </p:nvPr>
+        </p:nvSpPr>
+        <p:spPr/>
+        <p:txBody>
+          <a:bodyPr/>
+          <a:lstStyle/>
+          <a:p>
+            <a:r>
+              <a:rPr lang="en-US" dirty="0"/>
+              <a:t>Instruction Level Parallelism</a:t>
+            </a:r>
+            <a:endParaRPr lang="en-IN" dirty="0"/>
+          </a:p>
+        </p:txBody>
+      </p:sp>
+      <p:sp>
+        <p:nvSpPr>
+          <p:cNvPr id="3" name="Date Placeholder 2">
+            <a:extLst>
+              <a:ext uri="{FF2B5EF4-FFF2-40B4-BE49-F238E27FC236}">
+                <a16:creationId xmlns:a16="http://schemas.microsoft.com/office/drawing/2014/main" id="{D2067078-6B5A-1831-264E-20F57363F40B}"/>
+              </a:ext>
+            </a:extLst>
+          </p:cNvPr>
+          <p:cNvSpPr>
+            <a:spLocks noGrp="1"/>
+          </p:cNvSpPr>
+          <p:nvPr>
+            <p:ph type="dt" sz="half" idx="10"/>
+          </p:nvPr>
+        </p:nvSpPr>
+        <p:spPr/>
+        <p:txBody>
+          <a:bodyPr/>
+          <a:lstStyle/>
+          <a:p>
+            <a:pPr>
+              <a:defRPr/>
+            </a:pPr>
+            <a:r>
+              <a:rPr lang="en-US"/>
+              <a:t>21/12/2020</a:t>
+            </a:r>
+          </a:p>
+        </p:txBody>
+      </p:sp>
+      <p:sp>
+        <p:nvSpPr>
+          <p:cNvPr id="4" name="Slide Number Placeholder 3">
+            <a:extLst>
+              <a:ext uri="{FF2B5EF4-FFF2-40B4-BE49-F238E27FC236}">
+                <a16:creationId xmlns:a16="http://schemas.microsoft.com/office/drawing/2014/main" id="{2CC293E4-1C1C-23A9-C1C9-7750DE58F63B}"/>
+              </a:ext>
+            </a:extLst>
+          </p:cNvPr>
+          <p:cNvSpPr>
+            <a:spLocks noGrp="1"/>
+          </p:cNvSpPr>
+          <p:nvPr>
+            <p:ph type="sldNum" sz="quarter" idx="12"/>
+          </p:nvPr>
+        </p:nvSpPr>
+        <p:spPr/>
+        <p:txBody>
+          <a:bodyPr/>
+          <a:lstStyle/>
+          <a:p>
+            <a:pPr>
+              <a:defRPr/>
+            </a:pPr>
+            <a:fld id="{E79D9D01-1391-45E0-A9C5-C04635A43651}" type="slidenum">
+              <a:rPr lang="en-US" altLang="en-US" smtClean="0"/>
+              <a:pPr>
+                <a:defRPr/>
+              </a:pPr>
+              <a:t>8</a:t>
+            </a:fld>
+            <a:endParaRPr lang="en-US" altLang="en-US"/>
+          </a:p>
+        </p:txBody>
+      </p:sp>
+      <p:sp>
+        <p:nvSpPr>
+          <p:cNvPr id="5" name="Text Placeholder 4">
+            <a:extLst>
+              <a:ext uri="{FF2B5EF4-FFF2-40B4-BE49-F238E27FC236}">
+                <a16:creationId xmlns:a16="http://schemas.microsoft.com/office/drawing/2014/main" id="{7A1FEBBD-DAD7-CF44-8562-1E0CDE17C482}"/>
+              </a:ext>
+            </a:extLst>
+          </p:cNvPr>
+          <p:cNvSpPr>
+            <a:spLocks noGrp="1"/>
+          </p:cNvSpPr>
+          <p:nvPr>
+            <p:ph type="body" sz="quarter" idx="13"/>
+          </p:nvPr>
+        </p:nvSpPr>
+        <p:spPr/>
+        <p:txBody>
+          <a:bodyPr/>
+          <a:lstStyle/>
+          <a:p>
+            <a:pPr marL="0" indent="0">
+              <a:buNone/>
+            </a:pPr>
+            <a:r>
+              <a:rPr lang="en-US" dirty="0"/>
+              <a:t>Can we increase speed by executing multiple instructions parallelly?</a:t>
+            </a:r>
+          </a:p>
+          <a:p>
+            <a:pPr marL="0" indent="0">
+              <a:buNone/>
+            </a:pPr>
+            <a:endParaRPr lang="en-US" dirty="0"/>
+          </a:p>
+          <a:p>
+            <a:pPr marL="0" indent="0">
+              <a:buNone/>
+            </a:pPr>
+            <a:r>
+              <a:rPr lang="en-IN" dirty="0"/>
+              <a:t>Instructions Per Cycle (IPC) &gt; 1:</a:t>
+            </a:r>
+            <a:br>
+              <a:rPr lang="en-IN" dirty="0"/>
+            </a:br>
+            <a:r>
+              <a:rPr lang="en-IN" dirty="0"/>
+              <a:t>superscalar architectures</a:t>
+            </a:r>
+          </a:p>
+        </p:txBody>
+      </p:sp>
+    </p:spTree>
+    <p:extLst>
+      <p:ext uri="{BB962C8B-B14F-4D97-AF65-F5344CB8AC3E}">
+        <p14:creationId xmlns:p14="http://schemas.microsoft.com/office/powerpoint/2010/main" val="1628850927"/>
+      </p:ext>
+    </p:extLst>
+  </p:cSld>
+  <p:clrMapOvr>
+    <a:masterClrMapping/>
+  </p:clrMapOvr>
+</p:sld>
+</file>
+
 <file path=ppt/slides/slide9.xml><?xml version="1.0" encoding="utf-8"?>
 <p:sld xmlns:a="http://schemas.openxmlformats.org/drawingml/2006/main" xmlns:r="http://schemas.openxmlformats.org/officeDocument/2006/relationships" xmlns:p="http://schemas.openxmlformats.org/presentationml/2006/main">
   <p:cSld>
@@ -13912,10 +16746,121 @@
       </p:grpSpPr>
       <p:sp>
         <p:nvSpPr>
+          <p:cNvPr id="2" name="Title 1">
+            <a:extLst>
+              <a:ext uri="{FF2B5EF4-FFF2-40B4-BE49-F238E27FC236}">
+                <a16:creationId xmlns:a16="http://schemas.microsoft.com/office/drawing/2014/main" id="{5C0A0DE7-497A-8040-9A02-1791866B23C3}"/>
+              </a:ext>
+            </a:extLst>
+          </p:cNvPr>
+          <p:cNvSpPr>
+            <a:spLocks noGrp="1"/>
+          </p:cNvSpPr>
+          <p:nvPr>
+            <p:ph type="title"/>
+          </p:nvPr>
+        </p:nvSpPr>
+        <p:spPr>
+          <a:xfrm>
+            <a:off x="152400" y="53975"/>
+            <a:ext cx="6400800" cy="1195386"/>
+          </a:xfrm>
+        </p:spPr>
+        <p:txBody>
+          <a:bodyPr/>
+          <a:lstStyle/>
+          <a:p>
+            <a:r>
+              <a:rPr lang="en-US" dirty="0"/>
+              <a:t>What we need for parallelization</a:t>
+            </a:r>
+            <a:endParaRPr lang="en-IN" dirty="0"/>
+          </a:p>
+        </p:txBody>
+      </p:sp>
+      <p:sp>
+        <p:nvSpPr>
+          <p:cNvPr id="3" name="Content Placeholder 2">
+            <a:extLst>
+              <a:ext uri="{FF2B5EF4-FFF2-40B4-BE49-F238E27FC236}">
+                <a16:creationId xmlns:a16="http://schemas.microsoft.com/office/drawing/2014/main" id="{ABDCA766-77E5-B109-CE83-5A18359357A8}"/>
+              </a:ext>
+            </a:extLst>
+          </p:cNvPr>
+          <p:cNvSpPr>
+            <a:spLocks noGrp="1"/>
+          </p:cNvSpPr>
+          <p:nvPr>
+            <p:ph idx="1"/>
+          </p:nvPr>
+        </p:nvSpPr>
+        <p:spPr/>
+        <p:txBody>
+          <a:bodyPr>
+            <a:normAutofit lnSpcReduction="10000"/>
+          </a:bodyPr>
+          <a:lstStyle/>
+          <a:p>
+            <a:r>
+              <a:rPr lang="en-US" dirty="0"/>
+              <a:t>Multiple hardware units (integer arithmetic units, floating point units)</a:t>
+            </a:r>
+          </a:p>
+          <a:p>
+            <a:r>
+              <a:rPr lang="en-US" dirty="0"/>
+              <a:t>Multiple </a:t>
+            </a:r>
+            <a:r>
+              <a:rPr lang="en-US" dirty="0" err="1"/>
+              <a:t>RegFile</a:t>
+            </a:r>
+            <a:r>
+              <a:rPr lang="en-US" dirty="0"/>
+              <a:t> read and write ports</a:t>
+            </a:r>
+          </a:p>
+          <a:p>
+            <a:r>
+              <a:rPr lang="en-IN" dirty="0"/>
+              <a:t>Memory: parallelism via</a:t>
+            </a:r>
+          </a:p>
+          <a:p>
+            <a:pPr lvl="1"/>
+            <a:r>
+              <a:rPr lang="en-IN" dirty="0"/>
+              <a:t>hierarchy (next few classes)</a:t>
+            </a:r>
+          </a:p>
+          <a:p>
+            <a:pPr lvl="1"/>
+            <a:r>
+              <a:rPr lang="en-IN" dirty="0"/>
+              <a:t>scheduling (issue multiple load instructions simultaneously)</a:t>
+            </a:r>
+          </a:p>
+          <a:p>
+            <a:pPr lvl="1"/>
+            <a:r>
+              <a:rPr lang="en-IN" dirty="0"/>
+              <a:t>banking (even and odd addresses fetched simultaneously)</a:t>
+            </a:r>
+          </a:p>
+          <a:p>
+            <a:r>
+              <a:rPr lang="en-IN" dirty="0"/>
+              <a:t>Multiple instruction fetches (similar to memory^)</a:t>
+            </a:r>
+          </a:p>
+        </p:txBody>
+      </p:sp>
+      <p:sp>
+        <p:nvSpPr>
           <p:cNvPr id="4" name="Date Placeholder 3">
             <a:extLst>
               <a:ext uri="{FF2B5EF4-FFF2-40B4-BE49-F238E27FC236}">
-                <a16:creationId xmlns:a16="http://schemas.microsoft.com/office/drawing/2014/main" id="{9AD89538-9E43-3C55-D9F8-0A60ACC84C47}"/>
+                <a16:creationId xmlns:a16="http://schemas.microsoft.com/office/drawing/2014/main" id="{93EA7B22-A5D9-1544-00F3-87D01BF60ACE}"/>
               </a:ext>
             </a:extLst>
           </p:cNvPr>
@@ -13931,49 +16876,22 @@
           <a:bodyPr/>
           <a:lstStyle/>
           <a:p>
-            <a:fld id="{B4B13859-67C5-4393-B6C2-556CF3F770C0}" type="datetime3">
-              <a:rPr lang="en-US" smtClean="0"/>
-              <a:t>18 March 2026</a:t>
-            </a:fld>
-            <a:endParaRPr lang="en-US"/>
+            <a:pPr>
+              <a:defRPr/>
+            </a:pPr>
+            <a:r>
+              <a:rPr lang="en-US"/>
+              <a:t>21/12/2020</a:t>
+            </a:r>
           </a:p>
         </p:txBody>
       </p:sp>
       <p:sp>
         <p:nvSpPr>
-          <p:cNvPr id="5" name="Footer Placeholder 4">
+          <p:cNvPr id="5" name="Slide Number Placeholder 4">
             <a:extLst>
               <a:ext uri="{FF2B5EF4-FFF2-40B4-BE49-F238E27FC236}">
-                <a16:creationId xmlns:a16="http://schemas.microsoft.com/office/drawing/2014/main" id="{D2C40B51-E8A7-3290-CFC8-A80E5B0E2E3C}"/>
-              </a:ext>
-            </a:extLst>
-          </p:cNvPr>
-          <p:cNvSpPr>
-            <a:spLocks noGrp="1"/>
-          </p:cNvSpPr>
-          <p:nvPr>
-            <p:ph type="ftr" sz="quarter" idx="11"/>
-          </p:nvPr>
-        </p:nvSpPr>
-        <p:spPr/>
-        <p:txBody>
-          <a:bodyPr/>
-          <a:lstStyle/>
-          <a:p>
-            <a:r>
-              <a:rPr lang="en-US"/>
-              <a:t>ELL305: Computer Architecture</a:t>
-            </a:r>
-            <a:endParaRPr lang="en-US" dirty="0"/>
-          </a:p>
-        </p:txBody>
-      </p:sp>
-      <p:sp>
-        <p:nvSpPr>
-          <p:cNvPr id="6" name="Slide Number Placeholder 5">
-            <a:extLst>
-              <a:ext uri="{FF2B5EF4-FFF2-40B4-BE49-F238E27FC236}">
-                <a16:creationId xmlns:a16="http://schemas.microsoft.com/office/drawing/2014/main" id="{3F414D1D-02B9-1551-DD0A-1D522240C914}"/>
+                <a16:creationId xmlns:a16="http://schemas.microsoft.com/office/drawing/2014/main" id="{86F8B219-A715-AD7D-D619-CDB8927292E5}"/>
               </a:ext>
             </a:extLst>
           </p:cNvPr>
@@ -13989,54 +16907,406 @@
           <a:bodyPr/>
           <a:lstStyle/>
           <a:p>
-            <a:fld id="{98AC3541-01C1-4CA5-B68F-FEE868C7D1AF}" type="slidenum">
-              <a:rPr lang="en-US" smtClean="0"/>
+            <a:pPr>
+              <a:defRPr/>
+            </a:pPr>
+            <a:fld id="{CA887A73-1AE0-46F8-856A-18EA1CF30A1B}" type="slidenum">
+              <a:rPr lang="en-US" altLang="en-US" smtClean="0"/>
+              <a:pPr>
+                <a:defRPr/>
+              </a:pPr>
               <a:t>9</a:t>
             </a:fld>
-            <a:endParaRPr lang="en-US"/>
+            <a:endParaRPr lang="en-US" altLang="en-US"/>
           </a:p>
         </p:txBody>
       </p:sp>
-      <p:pic>
-        <p:nvPicPr>
-          <p:cNvPr id="8" name="Picture 7">
-            <a:extLst>
-              <a:ext uri="{FF2B5EF4-FFF2-40B4-BE49-F238E27FC236}">
-                <a16:creationId xmlns:a16="http://schemas.microsoft.com/office/drawing/2014/main" id="{C8F9BD40-F573-44C9-115C-5F880AFCFDF0}"/>
-              </a:ext>
-            </a:extLst>
-          </p:cNvPr>
-          <p:cNvPicPr>
-            <a:picLocks noChangeAspect="1"/>
-          </p:cNvPicPr>
-          <p:nvPr/>
-        </p:nvPicPr>
-        <p:blipFill>
-          <a:blip r:embed="rId2"/>
-          <a:stretch>
-            <a:fillRect/>
-          </a:stretch>
-        </p:blipFill>
-        <p:spPr>
-          <a:xfrm>
-            <a:off x="1188962" y="1178405"/>
-            <a:ext cx="6766076" cy="4501191"/>
-          </a:xfrm>
-          <a:prstGeom prst="rect">
-            <a:avLst/>
-          </a:prstGeom>
-        </p:spPr>
-      </p:pic>
     </p:spTree>
     <p:extLst>
       <p:ext uri="{BB962C8B-B14F-4D97-AF65-F5344CB8AC3E}">
-        <p14:creationId xmlns:p14="http://schemas.microsoft.com/office/powerpoint/2010/main" val="2493914522"/>
+        <p14:creationId xmlns:p14="http://schemas.microsoft.com/office/powerpoint/2010/main" val="4164819422"/>
       </p:ext>
     </p:extLst>
   </p:cSld>
   <p:clrMapOvr>
     <a:masterClrMapping/>
   </p:clrMapOvr>
+  <p:timing>
+    <p:tnLst>
+      <p:par>
+        <p:cTn id="1" dur="indefinite" restart="never" nodeType="tmRoot">
+          <p:childTnLst>
+            <p:seq concurrent="1" nextAc="seek">
+              <p:cTn id="2" dur="indefinite" nodeType="mainSeq">
+                <p:childTnLst>
+                  <p:par>
+                    <p:cTn id="3" fill="hold">
+                      <p:stCondLst>
+                        <p:cond delay="indefinite"/>
+                      </p:stCondLst>
+                      <p:childTnLst>
+                        <p:par>
+                          <p:cTn id="4" fill="hold">
+                            <p:stCondLst>
+                              <p:cond delay="0"/>
+                            </p:stCondLst>
+                            <p:childTnLst>
+                              <p:par>
+                                <p:cTn id="5" presetID="1" presetClass="entr" presetSubtype="0" fill="hold" grpId="0" nodeType="clickEffect">
+                                  <p:stCondLst>
+                                    <p:cond delay="0"/>
+                                  </p:stCondLst>
+                                  <p:childTnLst>
+                                    <p:set>
+                                      <p:cBhvr>
+                                        <p:cTn id="6" dur="1" fill="hold">
+                                          <p:stCondLst>
+                                            <p:cond delay="0"/>
+                                          </p:stCondLst>
+                                        </p:cTn>
+                                        <p:tgtEl>
+                                          <p:spTgt spid="3">
+                                            <p:txEl>
+                                              <p:pRg st="0" end="0"/>
+                                            </p:txEl>
+                                          </p:spTgt>
+                                        </p:tgtEl>
+                                        <p:attrNameLst>
+                                          <p:attrName>style.visibility</p:attrName>
+                                        </p:attrNameLst>
+                                      </p:cBhvr>
+                                      <p:to>
+                                        <p:strVal val="visible"/>
+                                      </p:to>
+                                    </p:set>
+                                  </p:childTnLst>
+                                </p:cTn>
+                              </p:par>
+                            </p:childTnLst>
+                          </p:cTn>
+                        </p:par>
+                      </p:childTnLst>
+                    </p:cTn>
+                  </p:par>
+                  <p:par>
+                    <p:cTn id="7" fill="hold">
+                      <p:stCondLst>
+                        <p:cond delay="indefinite"/>
+                      </p:stCondLst>
+                      <p:childTnLst>
+                        <p:par>
+                          <p:cTn id="8" fill="hold">
+                            <p:stCondLst>
+                              <p:cond delay="0"/>
+                            </p:stCondLst>
+                            <p:childTnLst>
+                              <p:par>
+                                <p:cTn id="9" presetID="1" presetClass="entr" presetSubtype="0" fill="hold" grpId="0" nodeType="clickEffect">
+                                  <p:stCondLst>
+                                    <p:cond delay="0"/>
+                                  </p:stCondLst>
+                                  <p:childTnLst>
+                                    <p:set>
+                                      <p:cBhvr>
+                                        <p:cTn id="10" dur="1" fill="hold">
+                                          <p:stCondLst>
+                                            <p:cond delay="0"/>
+                                          </p:stCondLst>
+                                        </p:cTn>
+                                        <p:tgtEl>
+                                          <p:spTgt spid="3">
+                                            <p:txEl>
+                                              <p:pRg st="1" end="1"/>
+                                            </p:txEl>
+                                          </p:spTgt>
+                                        </p:tgtEl>
+                                        <p:attrNameLst>
+                                          <p:attrName>style.visibility</p:attrName>
+                                        </p:attrNameLst>
+                                      </p:cBhvr>
+                                      <p:to>
+                                        <p:strVal val="visible"/>
+                                      </p:to>
+                                    </p:set>
+                                  </p:childTnLst>
+                                </p:cTn>
+                              </p:par>
+                            </p:childTnLst>
+                          </p:cTn>
+                        </p:par>
+                      </p:childTnLst>
+                    </p:cTn>
+                  </p:par>
+                  <p:par>
+                    <p:cTn id="11" fill="hold">
+                      <p:stCondLst>
+                        <p:cond delay="indefinite"/>
+                      </p:stCondLst>
+                      <p:childTnLst>
+                        <p:par>
+                          <p:cTn id="12" fill="hold">
+                            <p:stCondLst>
+                              <p:cond delay="0"/>
+                            </p:stCondLst>
+                            <p:childTnLst>
+                              <p:par>
+                                <p:cTn id="13" presetID="1" presetClass="entr" presetSubtype="0" fill="hold" grpId="0" nodeType="clickEffect">
+                                  <p:stCondLst>
+                                    <p:cond delay="0"/>
+                                  </p:stCondLst>
+                                  <p:childTnLst>
+                                    <p:set>
+                                      <p:cBhvr>
+                                        <p:cTn id="14" dur="1" fill="hold">
+                                          <p:stCondLst>
+                                            <p:cond delay="0"/>
+                                          </p:stCondLst>
+                                        </p:cTn>
+                                        <p:tgtEl>
+                                          <p:spTgt spid="3">
+                                            <p:txEl>
+                                              <p:pRg st="2" end="2"/>
+                                            </p:txEl>
+                                          </p:spTgt>
+                                        </p:tgtEl>
+                                        <p:attrNameLst>
+                                          <p:attrName>style.visibility</p:attrName>
+                                        </p:attrNameLst>
+                                      </p:cBhvr>
+                                      <p:to>
+                                        <p:strVal val="visible"/>
+                                      </p:to>
+                                    </p:set>
+                                  </p:childTnLst>
+                                </p:cTn>
+                              </p:par>
+                            </p:childTnLst>
+                          </p:cTn>
+                        </p:par>
+                      </p:childTnLst>
+                    </p:cTn>
+                  </p:par>
+                  <p:par>
+                    <p:cTn id="15" fill="hold">
+                      <p:stCondLst>
+                        <p:cond delay="indefinite"/>
+                      </p:stCondLst>
+                      <p:childTnLst>
+                        <p:par>
+                          <p:cTn id="16" fill="hold">
+                            <p:stCondLst>
+                              <p:cond delay="0"/>
+                            </p:stCondLst>
+                            <p:childTnLst>
+                              <p:par>
+                                <p:cTn id="17" presetID="1" presetClass="entr" presetSubtype="0" fill="hold" grpId="0" nodeType="clickEffect">
+                                  <p:stCondLst>
+                                    <p:cond delay="0"/>
+                                  </p:stCondLst>
+                                  <p:childTnLst>
+                                    <p:set>
+                                      <p:cBhvr>
+                                        <p:cTn id="18" dur="1" fill="hold">
+                                          <p:stCondLst>
+                                            <p:cond delay="0"/>
+                                          </p:stCondLst>
+                                        </p:cTn>
+                                        <p:tgtEl>
+                                          <p:spTgt spid="3">
+                                            <p:txEl>
+                                              <p:pRg st="3" end="3"/>
+                                            </p:txEl>
+                                          </p:spTgt>
+                                        </p:tgtEl>
+                                        <p:attrNameLst>
+                                          <p:attrName>style.visibility</p:attrName>
+                                        </p:attrNameLst>
+                                      </p:cBhvr>
+                                      <p:to>
+                                        <p:strVal val="visible"/>
+                                      </p:to>
+                                    </p:set>
+                                  </p:childTnLst>
+                                </p:cTn>
+                              </p:par>
+                            </p:childTnLst>
+                          </p:cTn>
+                        </p:par>
+                      </p:childTnLst>
+                    </p:cTn>
+                  </p:par>
+                  <p:par>
+                    <p:cTn id="19" fill="hold">
+                      <p:stCondLst>
+                        <p:cond delay="indefinite"/>
+                      </p:stCondLst>
+                      <p:childTnLst>
+                        <p:par>
+                          <p:cTn id="20" fill="hold">
+                            <p:stCondLst>
+                              <p:cond delay="0"/>
+                            </p:stCondLst>
+                            <p:childTnLst>
+                              <p:par>
+                                <p:cTn id="21" presetID="1" presetClass="entr" presetSubtype="0" fill="hold" grpId="0" nodeType="clickEffect">
+                                  <p:stCondLst>
+                                    <p:cond delay="0"/>
+                                  </p:stCondLst>
+                                  <p:childTnLst>
+                                    <p:set>
+                                      <p:cBhvr>
+                                        <p:cTn id="22" dur="1" fill="hold">
+                                          <p:stCondLst>
+                                            <p:cond delay="0"/>
+                                          </p:stCondLst>
+                                        </p:cTn>
+                                        <p:tgtEl>
+                                          <p:spTgt spid="3">
+                                            <p:txEl>
+                                              <p:pRg st="4" end="4"/>
+                                            </p:txEl>
+                                          </p:spTgt>
+                                        </p:tgtEl>
+                                        <p:attrNameLst>
+                                          <p:attrName>style.visibility</p:attrName>
+                                        </p:attrNameLst>
+                                      </p:cBhvr>
+                                      <p:to>
+                                        <p:strVal val="visible"/>
+                                      </p:to>
+                                    </p:set>
+                                  </p:childTnLst>
+                                </p:cTn>
+                              </p:par>
+                            </p:childTnLst>
+                          </p:cTn>
+                        </p:par>
+                      </p:childTnLst>
+                    </p:cTn>
+                  </p:par>
+                  <p:par>
+                    <p:cTn id="23" fill="hold">
+                      <p:stCondLst>
+                        <p:cond delay="indefinite"/>
+                      </p:stCondLst>
+                      <p:childTnLst>
+                        <p:par>
+                          <p:cTn id="24" fill="hold">
+                            <p:stCondLst>
+                              <p:cond delay="0"/>
+                            </p:stCondLst>
+                            <p:childTnLst>
+                              <p:par>
+                                <p:cTn id="25" presetID="1" presetClass="entr" presetSubtype="0" fill="hold" grpId="0" nodeType="clickEffect">
+                                  <p:stCondLst>
+                                    <p:cond delay="0"/>
+                                  </p:stCondLst>
+                                  <p:childTnLst>
+                                    <p:set>
+                                      <p:cBhvr>
+                                        <p:cTn id="26" dur="1" fill="hold">
+                                          <p:stCondLst>
+                                            <p:cond delay="0"/>
+                                          </p:stCondLst>
+                                        </p:cTn>
+                                        <p:tgtEl>
+                                          <p:spTgt spid="3">
+                                            <p:txEl>
+                                              <p:pRg st="5" end="5"/>
+                                            </p:txEl>
+                                          </p:spTgt>
+                                        </p:tgtEl>
+                                        <p:attrNameLst>
+                                          <p:attrName>style.visibility</p:attrName>
+                                        </p:attrNameLst>
+                                      </p:cBhvr>
+                                      <p:to>
+                                        <p:strVal val="visible"/>
+                                      </p:to>
+                                    </p:set>
+                                  </p:childTnLst>
+                                </p:cTn>
+                              </p:par>
+                            </p:childTnLst>
+                          </p:cTn>
+                        </p:par>
+                      </p:childTnLst>
+                    </p:cTn>
+                  </p:par>
+                  <p:par>
+                    <p:cTn id="27" fill="hold">
+                      <p:stCondLst>
+                        <p:cond delay="indefinite"/>
+                      </p:stCondLst>
+                      <p:childTnLst>
+                        <p:par>
+                          <p:cTn id="28" fill="hold">
+                            <p:stCondLst>
+                              <p:cond delay="0"/>
+                            </p:stCondLst>
+                            <p:childTnLst>
+                              <p:par>
+                                <p:cTn id="29" presetID="1" presetClass="entr" presetSubtype="0" fill="hold" grpId="0" nodeType="clickEffect">
+                                  <p:stCondLst>
+                                    <p:cond delay="0"/>
+                                  </p:stCondLst>
+                                  <p:childTnLst>
+                                    <p:set>
+                                      <p:cBhvr>
+                                        <p:cTn id="30" dur="1" fill="hold">
+                                          <p:stCondLst>
+                                            <p:cond delay="0"/>
+                                          </p:stCondLst>
+                                        </p:cTn>
+                                        <p:tgtEl>
+                                          <p:spTgt spid="3">
+                                            <p:txEl>
+                                              <p:pRg st="6" end="6"/>
+                                            </p:txEl>
+                                          </p:spTgt>
+                                        </p:tgtEl>
+                                        <p:attrNameLst>
+                                          <p:attrName>style.visibility</p:attrName>
+                                        </p:attrNameLst>
+                                      </p:cBhvr>
+                                      <p:to>
+                                        <p:strVal val="visible"/>
+                                      </p:to>
+                                    </p:set>
+                                  </p:childTnLst>
+                                </p:cTn>
+                              </p:par>
+                            </p:childTnLst>
+                          </p:cTn>
+                        </p:par>
+                      </p:childTnLst>
+                    </p:cTn>
+                  </p:par>
+                </p:childTnLst>
+              </p:cTn>
+              <p:prevCondLst>
+                <p:cond evt="onPrev" delay="0">
+                  <p:tgtEl>
+                    <p:sldTgt/>
+                  </p:tgtEl>
+                </p:cond>
+              </p:prevCondLst>
+              <p:nextCondLst>
+                <p:cond evt="onNext" delay="0">
+                  <p:tgtEl>
+                    <p:sldTgt/>
+                  </p:tgtEl>
+                </p:cond>
+              </p:nextCondLst>
+            </p:seq>
+          </p:childTnLst>
+        </p:cTn>
+      </p:par>
+    </p:tnLst>
+    <p:bldLst>
+      <p:bldP spid="3" grpId="0" build="p"/>
+    </p:bldLst>
+  </p:timing>
 </p:sld>
 </file>
 

</xml_diff>